<commit_message>
feat(payments): enable staff role payment access and update navigation to Payments
</commit_message>
<xml_diff>
--- a/LaundryCare_Presentation.pptx
+++ b/LaundryCare_Presentation.pptx
@@ -10,6 +10,7 @@
     <p:sldId id="258" r:id="rId9"/>
     <p:sldId id="259" r:id="rId10"/>
     <p:sldId id="260" r:id="rId11"/>
+    <p:sldId id="261" r:id="rId12"/>
   </p:sldIdLst>
   <p:sldSz cx="12191695" cy="6858000" type="screen4x3"/>
   <p:notesSz cx="6858000" cy="9144000"/>
@@ -3708,6 +3709,425 @@
               </a:defRPr>
             </a:pPr>
             <a:r>
+              <a:t>PROJECT INTRODUCTION   •   PRESENTER: JOHN MICHAEL BRETAÑA (LEAD ARCHITECT &amp; MANAGER)</a:t>
+            </a:r>
+          </a:p>
+          <a:p>
+            <a:pPr>
+              <a:spcBef>
+                <a:spcPts val="300"/>
+              </a:spcBef>
+              <a:defRPr sz="2000" b="1">
+                <a:solidFill>
+                  <a:srgbClr val="0F172A"/>
+                </a:solidFill>
+                <a:latin typeface="Arial"/>
+              </a:defRPr>
+            </a:pPr>
+            <a:r>
+              <a:t>System Introduction &amp; Project Overview</a:t>
+            </a:r>
+          </a:p>
+        </p:txBody>
+      </p:sp>
+      <p:sp>
+        <p:nvSpPr>
+          <p:cNvPr id="4" name="Rounded Rectangle 3"/>
+          <p:cNvSpPr/>
+          <p:nvPr/>
+        </p:nvSpPr>
+        <p:spPr>
+          <a:xfrm>
+            <a:off x="731520" y="1600200"/>
+            <a:ext cx="5266944" cy="4663440"/>
+          </a:xfrm>
+          <a:prstGeom prst="roundRect">
+            <a:avLst/>
+          </a:prstGeom>
+          <a:solidFill>
+            <a:srgbClr val="FFFFFF"/>
+          </a:solidFill>
+          <a:ln w="19050">
+            <a:solidFill>
+              <a:srgbClr val="E2E8F0"/>
+            </a:solidFill>
+          </a:ln>
+        </p:spPr>
+        <p:style>
+          <a:lnRef idx="1">
+            <a:schemeClr val="accent1"/>
+          </a:lnRef>
+          <a:fillRef idx="3">
+            <a:schemeClr val="accent1"/>
+          </a:fillRef>
+          <a:effectRef idx="2">
+            <a:schemeClr val="accent1"/>
+          </a:effectRef>
+          <a:fontRef idx="minor">
+            <a:schemeClr val="lt1"/>
+          </a:fontRef>
+        </p:style>
+        <p:txBody>
+          <a:bodyPr rtlCol="0" anchor="ctr" wrap="square" lIns="228600" tIns="182880" rIns="228600" bIns="182880"/>
+          <a:lstStyle/>
+          <a:p>
+            <a:pPr algn="ctr">
+              <a:spcAft>
+                <a:spcPts val="800"/>
+              </a:spcAft>
+              <a:defRPr sz="1500" b="1">
+                <a:solidFill>
+                  <a:srgbClr val="1E3A8A"/>
+                </a:solidFill>
+                <a:latin typeface="Arial"/>
+              </a:defRPr>
+            </a:pPr>
+            <a:r>
+              <a:t>🌟  What is LaundryCare?</a:t>
+            </a:r>
+          </a:p>
+          <a:p>
+            <a:pPr>
+              <a:spcBef>
+                <a:spcPts val="400"/>
+              </a:spcBef>
+              <a:spcAft>
+                <a:spcPts val="400"/>
+              </a:spcAft>
+              <a:defRPr sz="1200">
+                <a:solidFill>
+                  <a:srgbClr val="475569"/>
+                </a:solidFill>
+                <a:latin typeface="Calibri"/>
+              </a:defRPr>
+            </a:pPr>
+            <a:r>
+              <a:t>•  Core Purpose: A full-stack, cloud-deployed web ERP and doorstep logistics system engineered specifically for Barangay Base Camp, Maramag, Bukidnon.</a:t>
+            </a:r>
+          </a:p>
+          <a:p>
+            <a:pPr>
+              <a:spcBef>
+                <a:spcPts val="400"/>
+              </a:spcBef>
+              <a:spcAft>
+                <a:spcPts val="400"/>
+              </a:spcAft>
+              <a:defRPr sz="1200">
+                <a:solidFill>
+                  <a:srgbClr val="475569"/>
+                </a:solidFill>
+                <a:latin typeface="Calibri"/>
+              </a:defRPr>
+            </a:pPr>
+            <a:r>
+              <a:t>•  Digital Transformation: Replaces chaotic manual pen-and-paper booking with an automated, transparent, and paperless operational pipeline.</a:t>
+            </a:r>
+          </a:p>
+          <a:p>
+            <a:pPr>
+              <a:spcBef>
+                <a:spcPts val="400"/>
+              </a:spcBef>
+              <a:spcAft>
+                <a:spcPts val="400"/>
+              </a:spcAft>
+              <a:defRPr sz="1200">
+                <a:solidFill>
+                  <a:srgbClr val="475569"/>
+                </a:solidFill>
+                <a:latin typeface="Calibri"/>
+              </a:defRPr>
+            </a:pPr>
+            <a:r>
+              <a:t>•  Community Context: Tailored for Base Camp households, dormitories, and busy families who lack time or washing equipment.</a:t>
+            </a:r>
+          </a:p>
+          <a:p>
+            <a:pPr>
+              <a:spcBef>
+                <a:spcPts val="400"/>
+              </a:spcBef>
+              <a:spcAft>
+                <a:spcPts val="400"/>
+              </a:spcAft>
+              <a:defRPr sz="1200">
+                <a:solidFill>
+                  <a:srgbClr val="475569"/>
+                </a:solidFill>
+                <a:latin typeface="Calibri"/>
+              </a:defRPr>
+            </a:pPr>
+            <a:r>
+              <a:t>•  End-to-End Scope: Integrates customers, store cashiers, laundry machine operators, and motorcycle couriers into one centralized platform.</a:t>
+            </a:r>
+          </a:p>
+          <a:p>
+            <a:pPr>
+              <a:spcBef>
+                <a:spcPts val="400"/>
+              </a:spcBef>
+              <a:spcAft>
+                <a:spcPts val="400"/>
+              </a:spcAft>
+              <a:defRPr sz="1200">
+                <a:solidFill>
+                  <a:srgbClr val="475569"/>
+                </a:solidFill>
+                <a:latin typeface="Calibri"/>
+              </a:defRPr>
+            </a:pPr>
+            <a:r>
+              <a:t>•  Cloud Availability: Deployed live on Render PaaS (Linux Gunicorn WSGI) with local offline hot standby.</a:t>
+            </a:r>
+          </a:p>
+        </p:txBody>
+      </p:sp>
+      <p:sp>
+        <p:nvSpPr>
+          <p:cNvPr id="5" name="Rounded Rectangle 4"/>
+          <p:cNvSpPr/>
+          <p:nvPr/>
+        </p:nvSpPr>
+        <p:spPr>
+          <a:xfrm>
+            <a:off x="6181344" y="1600200"/>
+            <a:ext cx="5276088" cy="4663440"/>
+          </a:xfrm>
+          <a:prstGeom prst="roundRect">
+            <a:avLst/>
+          </a:prstGeom>
+          <a:solidFill>
+            <a:srgbClr val="FFFFFF"/>
+          </a:solidFill>
+          <a:ln w="19050">
+            <a:solidFill>
+              <a:srgbClr val="E2E8F0"/>
+            </a:solidFill>
+          </a:ln>
+        </p:spPr>
+        <p:style>
+          <a:lnRef idx="1">
+            <a:schemeClr val="accent1"/>
+          </a:lnRef>
+          <a:fillRef idx="3">
+            <a:schemeClr val="accent1"/>
+          </a:fillRef>
+          <a:effectRef idx="2">
+            <a:schemeClr val="accent1"/>
+          </a:effectRef>
+          <a:fontRef idx="minor">
+            <a:schemeClr val="lt1"/>
+          </a:fontRef>
+        </p:style>
+        <p:txBody>
+          <a:bodyPr rtlCol="0" anchor="ctr" wrap="square" lIns="228600" tIns="182880" rIns="228600" bIns="182880"/>
+          <a:lstStyle/>
+          <a:p>
+            <a:pPr algn="ctr">
+              <a:spcAft>
+                <a:spcPts val="800"/>
+              </a:spcAft>
+              <a:defRPr sz="1500" b="1">
+                <a:solidFill>
+                  <a:srgbClr val="1E3A8A"/>
+                </a:solidFill>
+                <a:latin typeface="Arial"/>
+              </a:defRPr>
+            </a:pPr>
+            <a:r>
+              <a:t>🏛️  The 3 Core Operational Pillars</a:t>
+            </a:r>
+          </a:p>
+          <a:p>
+            <a:pPr>
+              <a:spcBef>
+                <a:spcPts val="400"/>
+              </a:spcBef>
+              <a:spcAft>
+                <a:spcPts val="400"/>
+              </a:spcAft>
+              <a:defRPr sz="1200">
+                <a:solidFill>
+                  <a:srgbClr val="475569"/>
+                </a:solidFill>
+                <a:latin typeface="Calibri"/>
+              </a:defRPr>
+            </a:pPr>
+            <a:r>
+              <a:t>•  1. Public Customer Portal (Zero Login): 60-second doorstep pickup booking and real-time 5-stage tracking with GCash payment references.</a:t>
+            </a:r>
+          </a:p>
+          <a:p>
+            <a:pPr>
+              <a:spcBef>
+                <a:spcPts val="400"/>
+              </a:spcBef>
+              <a:spcAft>
+                <a:spcPts val="400"/>
+              </a:spcAft>
+              <a:defRPr sz="1200">
+                <a:solidFill>
+                  <a:srgbClr val="475569"/>
+                </a:solidFill>
+                <a:latin typeface="Calibri"/>
+              </a:defRPr>
+            </a:pPr>
+            <a:r>
+              <a:t>•  2. Centralized Store Operations: Digital scale intake, automated per-kilo pricing, dynamic loyalty tiering, and wash plant machine telemetry.</a:t>
+            </a:r>
+          </a:p>
+          <a:p>
+            <a:pPr>
+              <a:spcBef>
+                <a:spcPts val="400"/>
+              </a:spcBef>
+              <a:spcAft>
+                <a:spcPts val="400"/>
+              </a:spcAft>
+              <a:defRPr sz="1200">
+                <a:solidFill>
+                  <a:srgbClr val="475569"/>
+                </a:solidFill>
+                <a:latin typeface="Calibri"/>
+              </a:defRPr>
+            </a:pPr>
+            <a:r>
+              <a:t>•  3. Sector-Based Motorcycle Fleet: 100% motorcycle courier circuits across Base Camp with 1-tap GPS routing and touch signature proof-of-delivery.</a:t>
+            </a:r>
+          </a:p>
+          <a:p>
+            <a:pPr>
+              <a:spcBef>
+                <a:spcPts val="400"/>
+              </a:spcBef>
+              <a:spcAft>
+                <a:spcPts val="400"/>
+              </a:spcAft>
+              <a:defRPr sz="1200">
+                <a:solidFill>
+                  <a:srgbClr val="475569"/>
+                </a:solidFill>
+                <a:latin typeface="Calibri"/>
+              </a:defRPr>
+            </a:pPr>
+            <a:r>
+              <a:t>•  4. Software Quality Standards: Backed by 78 / 78 passing automated unit, integration, and adversarial tests (100% green suite).</a:t>
+            </a:r>
+          </a:p>
+        </p:txBody>
+      </p:sp>
+    </p:spTree>
+  </p:cSld>
+  <p:clrMapOvr>
+    <a:masterClrMapping/>
+  </p:clrMapOvr>
+</p:sld>
+</file>
+
+<file path=ppt/slides/slide3.xml><?xml version="1.0" encoding="utf-8"?>
+<p:sld xmlns:a="http://schemas.openxmlformats.org/drawingml/2006/main" xmlns:p="http://schemas.openxmlformats.org/presentationml/2006/main" xmlns:r="http://schemas.openxmlformats.org/officeDocument/2006/relationships">
+  <p:cSld>
+    <p:spTree>
+      <p:nvGrpSpPr>
+        <p:cNvPr id="1" name=""/>
+        <p:cNvGrpSpPr/>
+        <p:nvPr/>
+      </p:nvGrpSpPr>
+      <p:grpSpPr/>
+      <p:sp>
+        <p:nvSpPr>
+          <p:cNvPr id="2" name="Rectangle 1"/>
+          <p:cNvSpPr/>
+          <p:nvPr/>
+        </p:nvSpPr>
+        <p:spPr>
+          <a:xfrm>
+            <a:off x="0" y="0"/>
+            <a:ext cx="12191695" cy="6858000"/>
+          </a:xfrm>
+          <a:prstGeom prst="rect">
+            <a:avLst/>
+          </a:prstGeom>
+          <a:solidFill>
+            <a:srgbClr val="F8FAFC"/>
+          </a:solidFill>
+          <a:ln>
+            <a:noFill/>
+          </a:ln>
+        </p:spPr>
+        <p:style>
+          <a:lnRef idx="1">
+            <a:schemeClr val="accent1"/>
+          </a:lnRef>
+          <a:fillRef idx="3">
+            <a:schemeClr val="accent1"/>
+          </a:fillRef>
+          <a:effectRef idx="2">
+            <a:schemeClr val="accent1"/>
+          </a:effectRef>
+          <a:fontRef idx="minor">
+            <a:schemeClr val="lt1"/>
+          </a:fontRef>
+        </p:style>
+        <p:txBody>
+          <a:bodyPr rtlCol="0" anchor="ctr"/>
+          <a:lstStyle/>
+          <a:p>
+            <a:pPr algn="ctr"/>
+          </a:p>
+        </p:txBody>
+      </p:sp>
+      <p:sp>
+        <p:nvSpPr>
+          <p:cNvPr id="3" name="Rectangle 2"/>
+          <p:cNvSpPr/>
+          <p:nvPr/>
+        </p:nvSpPr>
+        <p:spPr>
+          <a:xfrm>
+            <a:off x="731520" y="365760"/>
+            <a:ext cx="10728655" cy="1005840"/>
+          </a:xfrm>
+          <a:prstGeom prst="rect">
+            <a:avLst/>
+          </a:prstGeom>
+          <a:solidFill>
+            <a:srgbClr val="FFFFFF"/>
+          </a:solidFill>
+          <a:ln w="12700">
+            <a:solidFill>
+              <a:srgbClr val="E2E8F0"/>
+            </a:solidFill>
+          </a:ln>
+        </p:spPr>
+        <p:style>
+          <a:lnRef idx="1">
+            <a:schemeClr val="accent1"/>
+          </a:lnRef>
+          <a:fillRef idx="3">
+            <a:schemeClr val="accent1"/>
+          </a:fillRef>
+          <a:effectRef idx="2">
+            <a:schemeClr val="accent1"/>
+          </a:effectRef>
+          <a:fontRef idx="minor">
+            <a:schemeClr val="lt1"/>
+          </a:fontRef>
+        </p:style>
+        <p:txBody>
+          <a:bodyPr rtlCol="0" anchor="ctr" wrap="square" lIns="228600" tIns="109728" rIns="228600" bIns="91440"/>
+          <a:lstStyle/>
+          <a:p>
+            <a:pPr algn="ctr">
+              <a:defRPr sz="1100" b="1">
+                <a:solidFill>
+                  <a:srgbClr val="2563EB"/>
+                </a:solidFill>
+                <a:latin typeface="Calibri"/>
+              </a:defRPr>
+            </a:pPr>
+            <a:r>
               <a:t>PHASE 1: PROBLEM DEFINITION   •   PRESENTER: HAZIL ENOC (STORE CASHIER &amp; CRM LEAD)</a:t>
             </a:r>
           </a:p>
@@ -4197,7 +4617,7 @@
 </p:sld>
 </file>
 
-<file path=ppt/slides/slide3.xml><?xml version="1.0" encoding="utf-8"?>
+<file path=ppt/slides/slide4.xml><?xml version="1.0" encoding="utf-8"?>
 <p:sld xmlns:a="http://schemas.openxmlformats.org/drawingml/2006/main" xmlns:p="http://schemas.openxmlformats.org/presentationml/2006/main" xmlns:r="http://schemas.openxmlformats.org/officeDocument/2006/relationships">
   <p:cSld>
     <p:spTree>
@@ -4731,7 +5151,7 @@
 </p:sld>
 </file>
 
-<file path=ppt/slides/slide4.xml><?xml version="1.0" encoding="utf-8"?>
+<file path=ppt/slides/slide5.xml><?xml version="1.0" encoding="utf-8"?>
 <p:sld xmlns:a="http://schemas.openxmlformats.org/drawingml/2006/main" xmlns:p="http://schemas.openxmlformats.org/presentationml/2006/main" xmlns:r="http://schemas.openxmlformats.org/officeDocument/2006/relationships">
   <p:cSld>
     <p:spTree>
@@ -5169,7 +5589,7 @@
 </p:sld>
 </file>
 
-<file path=ppt/slides/slide5.xml><?xml version="1.0" encoding="utf-8"?>
+<file path=ppt/slides/slide6.xml><?xml version="1.0" encoding="utf-8"?>
 <p:sld xmlns:a="http://schemas.openxmlformats.org/drawingml/2006/main" xmlns:p="http://schemas.openxmlformats.org/presentationml/2006/main" xmlns:r="http://schemas.openxmlformats.org/officeDocument/2006/relationships">
   <p:cSld>
     <p:spTree>

</xml_diff>

<commit_message>
docs(presentation): condense presentation deck to exactly 5 slides with live system demo workflow
</commit_message>
<xml_diff>
--- a/LaundryCare_Presentation.pptx
+++ b/LaundryCare_Presentation.pptx
@@ -10,7 +10,6 @@
     <p:sldId id="258" r:id="rId9"/>
     <p:sldId id="259" r:id="rId10"/>
     <p:sldId id="260" r:id="rId11"/>
-    <p:sldId id="261" r:id="rId12"/>
   </p:sldIdLst>
   <p:sldSz cx="12191695" cy="6858000" type="screen4x3"/>
   <p:notesSz cx="6858000" cy="9144000"/>
@@ -3184,7 +3183,7 @@
               </a:defRPr>
             </a:pPr>
             <a:r>
-              <a:t>CS 106 / SOFTWARE ENGINEERING 1  •  FINAL DEFENSE &amp; DEMO</a:t>
+              <a:t>CS 106 / SOFTWARE ENGINEERING 1  •  FINAL SYSTEM DEFENSE &amp; LIVE DEMO</a:t>
             </a:r>
           </a:p>
           <a:p>
@@ -3287,7 +3286,7 @@
               </a:defRPr>
             </a:pPr>
             <a:r>
-              <a:t>•  John Michael Bretaña — Lead Architect &amp; Project Manager</a:t>
+              <a:t>•  John Michael Bretaña — Lead Architect &amp; Branch Manager</a:t>
             </a:r>
           </a:p>
           <a:p>
@@ -3332,7 +3331,7 @@
               </a:defRPr>
             </a:pPr>
             <a:r>
-              <a:t>    Domain: Customer Loyalty Engine, Digital Weighing &amp; CRM</a:t>
+              <a:t>    Domain: Customer Loyalty Engine, Digital Weighing &amp; POS</a:t>
             </a:r>
           </a:p>
           <a:p>
@@ -3361,7 +3360,7 @@
               </a:defRPr>
             </a:pPr>
             <a:r>
-              <a:t>    Domain: Wash Hub Telemetry, Slot Densities &amp; Zone 3</a:t>
+              <a:t>    Domain: Wash Hub Telemetry, Machine Densities &amp; Zone 3</a:t>
             </a:r>
           </a:p>
           <a:p>
@@ -3490,7 +3489,7 @@
               </a:defRPr>
             </a:pPr>
             <a:r>
-              <a:t>✅ 78 / 78 Passing Tests</a:t>
+              <a:t>✅ 79 / 79 Passing Tests</a:t>
             </a:r>
           </a:p>
           <a:p>
@@ -3548,7 +3547,7 @@
               </a:defRPr>
             </a:pPr>
             <a:r>
-              <a:t>🛵 100% Motorcycle Fleet</a:t>
+              <a:t>🛵 100% Bajaj Motorcycle Fleet</a:t>
             </a:r>
           </a:p>
           <a:p>
@@ -3709,7 +3708,7 @@
               </a:defRPr>
             </a:pPr>
             <a:r>
-              <a:t>PROJECT INTRODUCTION   •   PRESENTER: JOHN MICHAEL BRETAÑA (LEAD ARCHITECT &amp; MANAGER)</a:t>
+              <a:t>PHASE 1: PROBLEM DEFINITION   •   PRESENTER: HAZIL ENOC (STORE CASHIER &amp; CRM LEAD)</a:t>
             </a:r>
           </a:p>
           <a:p>
@@ -3725,7 +3724,1133 @@
               </a:defRPr>
             </a:pPr>
             <a:r>
-              <a:t>System Introduction &amp; Project Overview</a:t>
+              <a:t>The Challenge: Operational Gaps in Traditional Laundry Shops</a:t>
+            </a:r>
+          </a:p>
+        </p:txBody>
+      </p:sp>
+      <p:sp>
+        <p:nvSpPr>
+          <p:cNvPr id="4" name="Rounded Rectangle 3"/>
+          <p:cNvSpPr/>
+          <p:nvPr/>
+        </p:nvSpPr>
+        <p:spPr>
+          <a:xfrm>
+            <a:off x="731520" y="1600200"/>
+            <a:ext cx="2542032" cy="4663440"/>
+          </a:xfrm>
+          <a:prstGeom prst="roundRect">
+            <a:avLst/>
+          </a:prstGeom>
+          <a:solidFill>
+            <a:srgbClr val="FFFFFF"/>
+          </a:solidFill>
+          <a:ln w="19050">
+            <a:solidFill>
+              <a:srgbClr val="E2E8F0"/>
+            </a:solidFill>
+          </a:ln>
+        </p:spPr>
+        <p:style>
+          <a:lnRef idx="1">
+            <a:schemeClr val="accent1"/>
+          </a:lnRef>
+          <a:fillRef idx="3">
+            <a:schemeClr val="accent1"/>
+          </a:fillRef>
+          <a:effectRef idx="2">
+            <a:schemeClr val="accent1"/>
+          </a:effectRef>
+          <a:fontRef idx="minor">
+            <a:schemeClr val="lt1"/>
+          </a:fontRef>
+        </p:style>
+        <p:txBody>
+          <a:bodyPr rtlCol="0" anchor="ctr" wrap="square" lIns="228600" tIns="182880" rIns="228600" bIns="182880"/>
+          <a:lstStyle/>
+          <a:p>
+            <a:pPr algn="ctr">
+              <a:spcAft>
+                <a:spcPts val="800"/>
+              </a:spcAft>
+              <a:defRPr sz="1500" b="1">
+                <a:solidFill>
+                  <a:srgbClr val="1E3A8A"/>
+                </a:solidFill>
+                <a:latin typeface="Arial"/>
+              </a:defRPr>
+            </a:pPr>
+            <a:r>
+              <a:t>🏷️  Lost Paper Slips &amp; Tags</a:t>
+            </a:r>
+          </a:p>
+          <a:p>
+            <a:pPr>
+              <a:spcBef>
+                <a:spcPts val="400"/>
+              </a:spcBef>
+              <a:spcAft>
+                <a:spcPts val="400"/>
+              </a:spcAft>
+              <a:defRPr sz="1200">
+                <a:solidFill>
+                  <a:srgbClr val="475569"/>
+                </a:solidFill>
+                <a:latin typeface="Calibri"/>
+              </a:defRPr>
+            </a:pPr>
+            <a:r>
+              <a:t>•  Physical paper receipts get torn, wet, or lost on the shop floor.</a:t>
+            </a:r>
+          </a:p>
+          <a:p>
+            <a:pPr>
+              <a:spcBef>
+                <a:spcPts val="400"/>
+              </a:spcBef>
+              <a:spcAft>
+                <a:spcPts val="400"/>
+              </a:spcAft>
+              <a:defRPr sz="1200">
+                <a:solidFill>
+                  <a:srgbClr val="475569"/>
+                </a:solidFill>
+                <a:latin typeface="Calibri"/>
+              </a:defRPr>
+            </a:pPr>
+            <a:r>
+              <a:t>•  Manual identification tags lead to misplaced garments and bag mix-ups.</a:t>
+            </a:r>
+          </a:p>
+          <a:p>
+            <a:pPr>
+              <a:spcBef>
+                <a:spcPts val="400"/>
+              </a:spcBef>
+              <a:spcAft>
+                <a:spcPts val="400"/>
+              </a:spcAft>
+              <a:defRPr sz="1200">
+                <a:solidFill>
+                  <a:srgbClr val="475569"/>
+                </a:solidFill>
+                <a:latin typeface="Calibri"/>
+              </a:defRPr>
+            </a:pPr>
+            <a:r>
+              <a:t>•  Zero permanent digital audit trail for customer service histories.</a:t>
+            </a:r>
+          </a:p>
+        </p:txBody>
+      </p:sp>
+      <p:sp>
+        <p:nvSpPr>
+          <p:cNvPr id="5" name="Rounded Rectangle 4"/>
+          <p:cNvSpPr/>
+          <p:nvPr/>
+        </p:nvSpPr>
+        <p:spPr>
+          <a:xfrm>
+            <a:off x="3456432" y="1600200"/>
+            <a:ext cx="2542032" cy="4663440"/>
+          </a:xfrm>
+          <a:prstGeom prst="roundRect">
+            <a:avLst/>
+          </a:prstGeom>
+          <a:solidFill>
+            <a:srgbClr val="FFFFFF"/>
+          </a:solidFill>
+          <a:ln w="19050">
+            <a:solidFill>
+              <a:srgbClr val="E2E8F0"/>
+            </a:solidFill>
+          </a:ln>
+        </p:spPr>
+        <p:style>
+          <a:lnRef idx="1">
+            <a:schemeClr val="accent1"/>
+          </a:lnRef>
+          <a:fillRef idx="3">
+            <a:schemeClr val="accent1"/>
+          </a:fillRef>
+          <a:effectRef idx="2">
+            <a:schemeClr val="accent1"/>
+          </a:effectRef>
+          <a:fontRef idx="minor">
+            <a:schemeClr val="lt1"/>
+          </a:fontRef>
+        </p:style>
+        <p:txBody>
+          <a:bodyPr rtlCol="0" anchor="ctr" wrap="square" lIns="228600" tIns="182880" rIns="228600" bIns="182880"/>
+          <a:lstStyle/>
+          <a:p>
+            <a:pPr algn="ctr">
+              <a:spcAft>
+                <a:spcPts val="800"/>
+              </a:spcAft>
+              <a:defRPr sz="1500" b="1">
+                <a:solidFill>
+                  <a:srgbClr val="1E3A8A"/>
+                </a:solidFill>
+                <a:latin typeface="Arial"/>
+              </a:defRPr>
+            </a:pPr>
+            <a:r>
+              <a:t>👀  Customer Blindspots</a:t>
+            </a:r>
+          </a:p>
+          <a:p>
+            <a:pPr>
+              <a:spcBef>
+                <a:spcPts val="400"/>
+              </a:spcBef>
+              <a:spcAft>
+                <a:spcPts val="400"/>
+              </a:spcAft>
+              <a:defRPr sz="1200">
+                <a:solidFill>
+                  <a:srgbClr val="475569"/>
+                </a:solidFill>
+                <a:latin typeface="Calibri"/>
+              </a:defRPr>
+            </a:pPr>
+            <a:r>
+              <a:t>•  Clients have zero visibility into washing and drying stages.</a:t>
+            </a:r>
+          </a:p>
+          <a:p>
+            <a:pPr>
+              <a:spcBef>
+                <a:spcPts val="400"/>
+              </a:spcBef>
+              <a:spcAft>
+                <a:spcPts val="400"/>
+              </a:spcAft>
+              <a:defRPr sz="1200">
+                <a:solidFill>
+                  <a:srgbClr val="475569"/>
+                </a:solidFill>
+                <a:latin typeface="Calibri"/>
+              </a:defRPr>
+            </a:pPr>
+            <a:r>
+              <a:t>•  Students and busy families repeatedly call staff asking if laundry is ready.</a:t>
+            </a:r>
+          </a:p>
+          <a:p>
+            <a:pPr>
+              <a:spcBef>
+                <a:spcPts val="400"/>
+              </a:spcBef>
+              <a:spcAft>
+                <a:spcPts val="400"/>
+              </a:spcAft>
+              <a:defRPr sz="1200">
+                <a:solidFill>
+                  <a:srgbClr val="475569"/>
+                </a:solidFill>
+                <a:latin typeface="Calibri"/>
+              </a:defRPr>
+            </a:pPr>
+            <a:r>
+              <a:t>•  No digital notifications when riders are en route for collection.</a:t>
+            </a:r>
+          </a:p>
+        </p:txBody>
+      </p:sp>
+      <p:sp>
+        <p:nvSpPr>
+          <p:cNvPr id="6" name="Rounded Rectangle 5"/>
+          <p:cNvSpPr/>
+          <p:nvPr/>
+        </p:nvSpPr>
+        <p:spPr>
+          <a:xfrm>
+            <a:off x="6181344" y="1600200"/>
+            <a:ext cx="2542032" cy="4663440"/>
+          </a:xfrm>
+          <a:prstGeom prst="roundRect">
+            <a:avLst/>
+          </a:prstGeom>
+          <a:solidFill>
+            <a:srgbClr val="FFFFFF"/>
+          </a:solidFill>
+          <a:ln w="19050">
+            <a:solidFill>
+              <a:srgbClr val="E2E8F0"/>
+            </a:solidFill>
+          </a:ln>
+        </p:spPr>
+        <p:style>
+          <a:lnRef idx="1">
+            <a:schemeClr val="accent1"/>
+          </a:lnRef>
+          <a:fillRef idx="3">
+            <a:schemeClr val="accent1"/>
+          </a:fillRef>
+          <a:effectRef idx="2">
+            <a:schemeClr val="accent1"/>
+          </a:effectRef>
+          <a:fontRef idx="minor">
+            <a:schemeClr val="lt1"/>
+          </a:fontRef>
+        </p:style>
+        <p:txBody>
+          <a:bodyPr rtlCol="0" anchor="ctr" wrap="square" lIns="228600" tIns="182880" rIns="228600" bIns="182880"/>
+          <a:lstStyle/>
+          <a:p>
+            <a:pPr algn="ctr">
+              <a:spcAft>
+                <a:spcPts val="800"/>
+              </a:spcAft>
+              <a:defRPr sz="1500" b="1">
+                <a:solidFill>
+                  <a:srgbClr val="1E3A8A"/>
+                </a:solidFill>
+                <a:latin typeface="Arial"/>
+              </a:defRPr>
+            </a:pPr>
+            <a:r>
+              <a:t>🛵  Uncoordinated Couriers</a:t>
+            </a:r>
+          </a:p>
+          <a:p>
+            <a:pPr>
+              <a:spcBef>
+                <a:spcPts val="400"/>
+              </a:spcBef>
+              <a:spcAft>
+                <a:spcPts val="400"/>
+              </a:spcAft>
+              <a:defRPr sz="1200">
+                <a:solidFill>
+                  <a:srgbClr val="475569"/>
+                </a:solidFill>
+                <a:latin typeface="Calibri"/>
+              </a:defRPr>
+            </a:pPr>
+            <a:r>
+              <a:t>•  Riders receive unstructured phone calls with unclear landmarks.</a:t>
+            </a:r>
+          </a:p>
+          <a:p>
+            <a:pPr>
+              <a:spcBef>
+                <a:spcPts val="400"/>
+              </a:spcBef>
+              <a:spcAft>
+                <a:spcPts val="400"/>
+              </a:spcAft>
+              <a:defRPr sz="1200">
+                <a:solidFill>
+                  <a:srgbClr val="475569"/>
+                </a:solidFill>
+                <a:latin typeface="Calibri"/>
+              </a:defRPr>
+            </a:pPr>
+            <a:r>
+              <a:t>•  No sector planning leads to overlapping routes and wasted fuel.</a:t>
+            </a:r>
+          </a:p>
+          <a:p>
+            <a:pPr>
+              <a:spcBef>
+                <a:spcPts val="400"/>
+              </a:spcBef>
+              <a:spcAft>
+                <a:spcPts val="400"/>
+              </a:spcAft>
+              <a:defRPr sz="1200">
+                <a:solidFill>
+                  <a:srgbClr val="475569"/>
+                </a:solidFill>
+                <a:latin typeface="Calibri"/>
+              </a:defRPr>
+            </a:pPr>
+            <a:r>
+              <a:t>•  Peak intake hours overwhelm couriers without scheduling density checks.</a:t>
+            </a:r>
+          </a:p>
+        </p:txBody>
+      </p:sp>
+      <p:sp>
+        <p:nvSpPr>
+          <p:cNvPr id="7" name="Rounded Rectangle 6"/>
+          <p:cNvSpPr/>
+          <p:nvPr/>
+        </p:nvSpPr>
+        <p:spPr>
+          <a:xfrm>
+            <a:off x="8906256" y="1600200"/>
+            <a:ext cx="2542032" cy="4663440"/>
+          </a:xfrm>
+          <a:prstGeom prst="roundRect">
+            <a:avLst/>
+          </a:prstGeom>
+          <a:solidFill>
+            <a:srgbClr val="FFFFFF"/>
+          </a:solidFill>
+          <a:ln w="19050">
+            <a:solidFill>
+              <a:srgbClr val="E2E8F0"/>
+            </a:solidFill>
+          </a:ln>
+        </p:spPr>
+        <p:style>
+          <a:lnRef idx="1">
+            <a:schemeClr val="accent1"/>
+          </a:lnRef>
+          <a:fillRef idx="3">
+            <a:schemeClr val="accent1"/>
+          </a:fillRef>
+          <a:effectRef idx="2">
+            <a:schemeClr val="accent1"/>
+          </a:effectRef>
+          <a:fontRef idx="minor">
+            <a:schemeClr val="lt1"/>
+          </a:fontRef>
+        </p:style>
+        <p:txBody>
+          <a:bodyPr rtlCol="0" anchor="ctr" wrap="square" lIns="228600" tIns="182880" rIns="228600" bIns="182880"/>
+          <a:lstStyle/>
+          <a:p>
+            <a:pPr algn="ctr">
+              <a:spcAft>
+                <a:spcPts val="800"/>
+              </a:spcAft>
+              <a:defRPr sz="1500" b="1">
+                <a:solidFill>
+                  <a:srgbClr val="1E3A8A"/>
+                </a:solidFill>
+                <a:latin typeface="Arial"/>
+              </a:defRPr>
+            </a:pPr>
+            <a:r>
+              <a:t>🧮  Doorstep Math Errors</a:t>
+            </a:r>
+          </a:p>
+          <a:p>
+            <a:pPr>
+              <a:spcBef>
+                <a:spcPts val="400"/>
+              </a:spcBef>
+              <a:spcAft>
+                <a:spcPts val="400"/>
+              </a:spcAft>
+              <a:defRPr sz="1200">
+                <a:solidFill>
+                  <a:srgbClr val="475569"/>
+                </a:solidFill>
+                <a:latin typeface="Calibri"/>
+              </a:defRPr>
+            </a:pPr>
+            <a:r>
+              <a:t>•  Couriers mentally compute per-kilogram rates and cash change on the road.</a:t>
+            </a:r>
+          </a:p>
+          <a:p>
+            <a:pPr>
+              <a:spcBef>
+                <a:spcPts val="400"/>
+              </a:spcBef>
+              <a:spcAft>
+                <a:spcPts val="400"/>
+              </a:spcAft>
+              <a:defRPr sz="1200">
+                <a:solidFill>
+                  <a:srgbClr val="475569"/>
+                </a:solidFill>
+                <a:latin typeface="Calibri"/>
+              </a:defRPr>
+            </a:pPr>
+            <a:r>
+              <a:t>•  Cashier end-of-day reconciliation deficits from arithmetic mistakes.</a:t>
+            </a:r>
+          </a:p>
+          <a:p>
+            <a:pPr>
+              <a:spcBef>
+                <a:spcPts val="400"/>
+              </a:spcBef>
+              <a:spcAft>
+                <a:spcPts val="400"/>
+              </a:spcAft>
+              <a:defRPr sz="1200">
+                <a:solidFill>
+                  <a:srgbClr val="475569"/>
+                </a:solidFill>
+                <a:latin typeface="Calibri"/>
+              </a:defRPr>
+            </a:pPr>
+            <a:r>
+              <a:t>•  Lack of digital Proof of Delivery (POD) signatures causes disputes.</a:t>
+            </a:r>
+          </a:p>
+        </p:txBody>
+      </p:sp>
+    </p:spTree>
+  </p:cSld>
+  <p:clrMapOvr>
+    <a:masterClrMapping/>
+  </p:clrMapOvr>
+</p:sld>
+</file>
+
+<file path=ppt/slides/slide3.xml><?xml version="1.0" encoding="utf-8"?>
+<p:sld xmlns:a="http://schemas.openxmlformats.org/drawingml/2006/main" xmlns:p="http://schemas.openxmlformats.org/presentationml/2006/main" xmlns:r="http://schemas.openxmlformats.org/officeDocument/2006/relationships">
+  <p:cSld>
+    <p:spTree>
+      <p:nvGrpSpPr>
+        <p:cNvPr id="1" name=""/>
+        <p:cNvGrpSpPr/>
+        <p:nvPr/>
+      </p:nvGrpSpPr>
+      <p:grpSpPr/>
+      <p:sp>
+        <p:nvSpPr>
+          <p:cNvPr id="2" name="Rectangle 1"/>
+          <p:cNvSpPr/>
+          <p:nvPr/>
+        </p:nvSpPr>
+        <p:spPr>
+          <a:xfrm>
+            <a:off x="0" y="0"/>
+            <a:ext cx="12191695" cy="6858000"/>
+          </a:xfrm>
+          <a:prstGeom prst="rect">
+            <a:avLst/>
+          </a:prstGeom>
+          <a:solidFill>
+            <a:srgbClr val="F8FAFC"/>
+          </a:solidFill>
+          <a:ln>
+            <a:noFill/>
+          </a:ln>
+        </p:spPr>
+        <p:style>
+          <a:lnRef idx="1">
+            <a:schemeClr val="accent1"/>
+          </a:lnRef>
+          <a:fillRef idx="3">
+            <a:schemeClr val="accent1"/>
+          </a:fillRef>
+          <a:effectRef idx="2">
+            <a:schemeClr val="accent1"/>
+          </a:effectRef>
+          <a:fontRef idx="minor">
+            <a:schemeClr val="lt1"/>
+          </a:fontRef>
+        </p:style>
+        <p:txBody>
+          <a:bodyPr rtlCol="0" anchor="ctr"/>
+          <a:lstStyle/>
+          <a:p>
+            <a:pPr algn="ctr"/>
+          </a:p>
+        </p:txBody>
+      </p:sp>
+      <p:sp>
+        <p:nvSpPr>
+          <p:cNvPr id="3" name="Rectangle 2"/>
+          <p:cNvSpPr/>
+          <p:nvPr/>
+        </p:nvSpPr>
+        <p:spPr>
+          <a:xfrm>
+            <a:off x="731520" y="365760"/>
+            <a:ext cx="10728655" cy="1005840"/>
+          </a:xfrm>
+          <a:prstGeom prst="rect">
+            <a:avLst/>
+          </a:prstGeom>
+          <a:solidFill>
+            <a:srgbClr val="FFFFFF"/>
+          </a:solidFill>
+          <a:ln w="12700">
+            <a:solidFill>
+              <a:srgbClr val="E2E8F0"/>
+            </a:solidFill>
+          </a:ln>
+        </p:spPr>
+        <p:style>
+          <a:lnRef idx="1">
+            <a:schemeClr val="accent1"/>
+          </a:lnRef>
+          <a:fillRef idx="3">
+            <a:schemeClr val="accent1"/>
+          </a:fillRef>
+          <a:effectRef idx="2">
+            <a:schemeClr val="accent1"/>
+          </a:effectRef>
+          <a:fontRef idx="minor">
+            <a:schemeClr val="lt1"/>
+          </a:fontRef>
+        </p:style>
+        <p:txBody>
+          <a:bodyPr rtlCol="0" anchor="ctr" wrap="square" lIns="228600" tIns="109728" rIns="228600" bIns="91440"/>
+          <a:lstStyle/>
+          <a:p>
+            <a:pPr algn="ctr">
+              <a:defRPr sz="1100" b="1">
+                <a:solidFill>
+                  <a:srgbClr val="2563EB"/>
+                </a:solidFill>
+                <a:latin typeface="Calibri"/>
+              </a:defRPr>
+            </a:pPr>
+            <a:r>
+              <a:t>PHASE 2: SOLUTION ARCHITECTURE   •   PRESENTER: MARK EPHRAIM NICOR (LAUNDRY OPERATOR &amp; COURIER 3)</a:t>
+            </a:r>
+          </a:p>
+          <a:p>
+            <a:pPr>
+              <a:spcBef>
+                <a:spcPts val="300"/>
+              </a:spcBef>
+              <a:defRPr sz="2000" b="1">
+                <a:solidFill>
+                  <a:srgbClr val="0F172A"/>
+                </a:solidFill>
+                <a:latin typeface="Arial"/>
+              </a:defRPr>
+            </a:pPr>
+            <a:r>
+              <a:t>The LaundryCare Solution: 3 Unified Portals</a:t>
+            </a:r>
+          </a:p>
+        </p:txBody>
+      </p:sp>
+      <p:sp>
+        <p:nvSpPr>
+          <p:cNvPr id="4" name="Rounded Rectangle 3"/>
+          <p:cNvSpPr/>
+          <p:nvPr/>
+        </p:nvSpPr>
+        <p:spPr>
+          <a:xfrm>
+            <a:off x="731520" y="1600200"/>
+            <a:ext cx="3447288" cy="4663440"/>
+          </a:xfrm>
+          <a:prstGeom prst="roundRect">
+            <a:avLst/>
+          </a:prstGeom>
+          <a:solidFill>
+            <a:srgbClr val="FFFFFF"/>
+          </a:solidFill>
+          <a:ln w="19050">
+            <a:solidFill>
+              <a:srgbClr val="E2E8F0"/>
+            </a:solidFill>
+          </a:ln>
+        </p:spPr>
+        <p:style>
+          <a:lnRef idx="1">
+            <a:schemeClr val="accent1"/>
+          </a:lnRef>
+          <a:fillRef idx="3">
+            <a:schemeClr val="accent1"/>
+          </a:fillRef>
+          <a:effectRef idx="2">
+            <a:schemeClr val="accent1"/>
+          </a:effectRef>
+          <a:fontRef idx="minor">
+            <a:schemeClr val="lt1"/>
+          </a:fontRef>
+        </p:style>
+        <p:txBody>
+          <a:bodyPr rtlCol="0" anchor="ctr" wrap="square" lIns="228600" tIns="182880" rIns="228600" bIns="182880"/>
+          <a:lstStyle/>
+          <a:p>
+            <a:pPr algn="ctr">
+              <a:spcAft>
+                <a:spcPts val="800"/>
+              </a:spcAft>
+              <a:defRPr sz="1500" b="1">
+                <a:solidFill>
+                  <a:srgbClr val="1E3A8A"/>
+                </a:solidFill>
+                <a:latin typeface="Arial"/>
+              </a:defRPr>
+            </a:pPr>
+            <a:r>
+              <a:t>📱  Public Customer Portal</a:t>
+            </a:r>
+          </a:p>
+          <a:p>
+            <a:pPr>
+              <a:spcBef>
+                <a:spcPts val="400"/>
+              </a:spcBef>
+              <a:spcAft>
+                <a:spcPts val="400"/>
+              </a:spcAft>
+              <a:defRPr sz="1200">
+                <a:solidFill>
+                  <a:srgbClr val="475569"/>
+                </a:solidFill>
+                <a:latin typeface="Calibri"/>
+              </a:defRPr>
+            </a:pPr>
+            <a:r>
+              <a:t>•  Zero Login Required: Frictionless access for dormitory students and residents.</a:t>
+            </a:r>
+          </a:p>
+          <a:p>
+            <a:pPr>
+              <a:spcBef>
+                <a:spcPts val="400"/>
+              </a:spcBef>
+              <a:spcAft>
+                <a:spcPts val="400"/>
+              </a:spcAft>
+              <a:defRPr sz="1200">
+                <a:solidFill>
+                  <a:srgbClr val="475569"/>
+                </a:solidFill>
+                <a:latin typeface="Calibri"/>
+              </a:defRPr>
+            </a:pPr>
+            <a:r>
+              <a:t>•  60-Second Online Booking (/book-pickup): Sector-based pickup scheduling.</a:t>
+            </a:r>
+          </a:p>
+          <a:p>
+            <a:pPr>
+              <a:spcBef>
+                <a:spcPts val="400"/>
+              </a:spcBef>
+              <a:spcAft>
+                <a:spcPts val="400"/>
+              </a:spcAft>
+              <a:defRPr sz="1200">
+                <a:solidFill>
+                  <a:srgbClr val="475569"/>
+                </a:solidFill>
+                <a:latin typeface="Calibri"/>
+              </a:defRPr>
+            </a:pPr>
+            <a:r>
+              <a:t>•  Live Real-Time Tracker (/track): 5-step progress bar from intake to doorstep drop-off.</a:t>
+            </a:r>
+          </a:p>
+          <a:p>
+            <a:pPr>
+              <a:spcBef>
+                <a:spcPts val="400"/>
+              </a:spcBef>
+              <a:spcAft>
+                <a:spcPts val="400"/>
+              </a:spcAft>
+              <a:defRPr sz="1200">
+                <a:solidFill>
+                  <a:srgbClr val="475569"/>
+                </a:solidFill>
+                <a:latin typeface="Calibri"/>
+              </a:defRPr>
+            </a:pPr>
+            <a:r>
+              <a:t>•  Transparent Payments: Electronic GCash/Maya reference modal.</a:t>
+            </a:r>
+          </a:p>
+        </p:txBody>
+      </p:sp>
+      <p:sp>
+        <p:nvSpPr>
+          <p:cNvPr id="5" name="Rounded Rectangle 4"/>
+          <p:cNvSpPr/>
+          <p:nvPr/>
+        </p:nvSpPr>
+        <p:spPr>
+          <a:xfrm>
+            <a:off x="4361688" y="1600200"/>
+            <a:ext cx="3447288" cy="4663440"/>
+          </a:xfrm>
+          <a:prstGeom prst="roundRect">
+            <a:avLst/>
+          </a:prstGeom>
+          <a:solidFill>
+            <a:srgbClr val="FFFFFF"/>
+          </a:solidFill>
+          <a:ln w="19050">
+            <a:solidFill>
+              <a:srgbClr val="E2E8F0"/>
+            </a:solidFill>
+          </a:ln>
+        </p:spPr>
+        <p:style>
+          <a:lnRef idx="1">
+            <a:schemeClr val="accent1"/>
+          </a:lnRef>
+          <a:fillRef idx="3">
+            <a:schemeClr val="accent1"/>
+          </a:fillRef>
+          <a:effectRef idx="2">
+            <a:schemeClr val="accent1"/>
+          </a:effectRef>
+          <a:fontRef idx="minor">
+            <a:schemeClr val="lt1"/>
+          </a:fontRef>
+        </p:style>
+        <p:txBody>
+          <a:bodyPr rtlCol="0" anchor="ctr" wrap="square" lIns="228600" tIns="182880" rIns="228600" bIns="182880"/>
+          <a:lstStyle/>
+          <a:p>
+            <a:pPr algn="ctr">
+              <a:spcAft>
+                <a:spcPts val="800"/>
+              </a:spcAft>
+              <a:defRPr sz="1500" b="1">
+                <a:solidFill>
+                  <a:srgbClr val="1E3A8A"/>
+                </a:solidFill>
+                <a:latin typeface="Arial"/>
+              </a:defRPr>
+            </a:pPr>
+            <a:r>
+              <a:t>🧺  Cashier &amp; Wash Operations</a:t>
+            </a:r>
+          </a:p>
+          <a:p>
+            <a:pPr>
+              <a:spcBef>
+                <a:spcPts val="400"/>
+              </a:spcBef>
+              <a:spcAft>
+                <a:spcPts val="400"/>
+              </a:spcAft>
+              <a:defRPr sz="1200">
+                <a:solidFill>
+                  <a:srgbClr val="475569"/>
+                </a:solidFill>
+                <a:latin typeface="Calibri"/>
+              </a:defRPr>
+            </a:pPr>
+            <a:r>
+              <a:t>•  Customer CRM Directory (/customers-page): Lifetime spend &amp; loyalty tier tracking.</a:t>
+            </a:r>
+          </a:p>
+          <a:p>
+            <a:pPr>
+              <a:spcBef>
+                <a:spcPts val="400"/>
+              </a:spcBef>
+              <a:spcAft>
+                <a:spcPts val="400"/>
+              </a:spcAft>
+              <a:defRPr sz="1200">
+                <a:solidFill>
+                  <a:srgbClr val="475569"/>
+                </a:solidFill>
+                <a:latin typeface="Calibri"/>
+              </a:defRPr>
+            </a:pPr>
+            <a:r>
+              <a:t>•  Digital Scale Intake (/laundry-orders-page): Auto-pricing calculation (Weight x Rate).</a:t>
+            </a:r>
+          </a:p>
+          <a:p>
+            <a:pPr>
+              <a:spcBef>
+                <a:spcPts val="400"/>
+              </a:spcBef>
+              <a:spcAft>
+                <a:spcPts val="400"/>
+              </a:spcAft>
+              <a:defRPr sz="1200">
+                <a:solidFill>
+                  <a:srgbClr val="475569"/>
+                </a:solidFill>
+                <a:latin typeface="Calibri"/>
+              </a:defRPr>
+            </a:pPr>
+            <a:r>
+              <a:t>•  Wash Hub Monitor (/pickup-schedules-page): Live capacity telemetry for 6 washers &amp; 4 dryers.</a:t>
+            </a:r>
+          </a:p>
+          <a:p>
+            <a:pPr>
+              <a:spcBef>
+                <a:spcPts val="400"/>
+              </a:spcBef>
+              <a:spcAft>
+                <a:spcPts val="400"/>
+              </a:spcAft>
+              <a:defRPr sz="1200">
+                <a:solidFill>
+                  <a:srgbClr val="475569"/>
+                </a:solidFill>
+                <a:latin typeface="Calibri"/>
+              </a:defRPr>
+            </a:pPr>
+            <a:r>
+              <a:t>•  Payments &amp; Settlement (/payments-page): Walk-in settlement &amp; POS payment recording.</a:t>
+            </a:r>
+          </a:p>
+        </p:txBody>
+      </p:sp>
+      <p:sp>
+        <p:nvSpPr>
+          <p:cNvPr id="6" name="Rounded Rectangle 5"/>
+          <p:cNvSpPr/>
+          <p:nvPr/>
+        </p:nvSpPr>
+        <p:spPr>
+          <a:xfrm>
+            <a:off x="7991856" y="1600200"/>
+            <a:ext cx="3447288" cy="4663440"/>
+          </a:xfrm>
+          <a:prstGeom prst="roundRect">
+            <a:avLst/>
+          </a:prstGeom>
+          <a:solidFill>
+            <a:srgbClr val="FFFFFF"/>
+          </a:solidFill>
+          <a:ln w="19050">
+            <a:solidFill>
+              <a:srgbClr val="E2E8F0"/>
+            </a:solidFill>
+          </a:ln>
+        </p:spPr>
+        <p:style>
+          <a:lnRef idx="1">
+            <a:schemeClr val="accent1"/>
+          </a:lnRef>
+          <a:fillRef idx="3">
+            <a:schemeClr val="accent1"/>
+          </a:fillRef>
+          <a:effectRef idx="2">
+            <a:schemeClr val="accent1"/>
+          </a:effectRef>
+          <a:fontRef idx="minor">
+            <a:schemeClr val="lt1"/>
+          </a:fontRef>
+        </p:style>
+        <p:txBody>
+          <a:bodyPr rtlCol="0" anchor="ctr" wrap="square" lIns="228600" tIns="182880" rIns="228600" bIns="182880"/>
+          <a:lstStyle/>
+          <a:p>
+            <a:pPr algn="ctr">
+              <a:spcAft>
+                <a:spcPts val="800"/>
+              </a:spcAft>
+              <a:defRPr sz="1500" b="1">
+                <a:solidFill>
+                  <a:srgbClr val="1E3A8A"/>
+                </a:solidFill>
+                <a:latin typeface="Arial"/>
+              </a:defRPr>
+            </a:pPr>
+            <a:r>
+              <a:t>🛵  Rider Mobile Web App</a:t>
+            </a:r>
+          </a:p>
+          <a:p>
+            <a:pPr>
+              <a:spcBef>
+                <a:spcPts val="400"/>
+              </a:spcBef>
+              <a:spcAft>
+                <a:spcPts val="400"/>
+              </a:spcAft>
+              <a:defRPr sz="1200">
+                <a:solidFill>
+                  <a:srgbClr val="475569"/>
+                </a:solidFill>
+                <a:latin typeface="Calibri"/>
+              </a:defRPr>
+            </a:pPr>
+            <a:r>
+              <a:t>•  Field Courier Interface (/rider-app): Optimized for motorcycle smartphone mounts.</a:t>
+            </a:r>
+          </a:p>
+          <a:p>
+            <a:pPr>
+              <a:spcBef>
+                <a:spcPts val="400"/>
+              </a:spcBef>
+              <a:spcAft>
+                <a:spcPts val="400"/>
+              </a:spcAft>
+              <a:defRPr sz="1200">
+                <a:solidFill>
+                  <a:srgbClr val="475569"/>
+                </a:solidFill>
+                <a:latin typeface="Calibri"/>
+              </a:defRPr>
+            </a:pPr>
+            <a:r>
+              <a:t>•  1-Tap GPS Navigation: Direct shortcuts into Google Maps &amp; Waze.</a:t>
+            </a:r>
+          </a:p>
+          <a:p>
+            <a:pPr>
+              <a:spcBef>
+                <a:spcPts val="400"/>
+              </a:spcBef>
+              <a:spcAft>
+                <a:spcPts val="400"/>
+              </a:spcAft>
+              <a:defRPr sz="1200">
+                <a:solidFill>
+                  <a:srgbClr val="475569"/>
+                </a:solidFill>
+                <a:latin typeface="Calibri"/>
+              </a:defRPr>
+            </a:pPr>
+            <a:r>
+              <a:t>•  Quick Client Calling: 1-tap phone dialer for arrival coordination.</a:t>
+            </a:r>
+          </a:p>
+          <a:p>
+            <a:pPr>
+              <a:spcBef>
+                <a:spcPts val="400"/>
+              </a:spcBef>
+              <a:spcAft>
+                <a:spcPts val="400"/>
+              </a:spcAft>
+              <a:defRPr sz="1200">
+                <a:solidFill>
+                  <a:srgbClr val="475569"/>
+                </a:solidFill>
+                <a:latin typeface="Calibri"/>
+              </a:defRPr>
+            </a:pPr>
+            <a:r>
+              <a:t>•  HTML5 Signature Canvas: Paperless touch signature handover.</a:t>
+            </a:r>
+          </a:p>
+        </p:txBody>
+      </p:sp>
+    </p:spTree>
+  </p:cSld>
+  <p:clrMapOvr>
+    <a:masterClrMapping/>
+  </p:clrMapOvr>
+</p:sld>
+</file>
+
+<file path=ppt/slides/slide4.xml><?xml version="1.0" encoding="utf-8"?>
+<p:sld xmlns:a="http://schemas.openxmlformats.org/drawingml/2006/main" xmlns:p="http://schemas.openxmlformats.org/presentationml/2006/main" xmlns:r="http://schemas.openxmlformats.org/officeDocument/2006/relationships">
+  <p:cSld>
+    <p:spTree>
+      <p:nvGrpSpPr>
+        <p:cNvPr id="1" name=""/>
+        <p:cNvGrpSpPr/>
+        <p:nvPr/>
+      </p:nvGrpSpPr>
+      <p:grpSpPr/>
+      <p:sp>
+        <p:nvSpPr>
+          <p:cNvPr id="2" name="Rectangle 1"/>
+          <p:cNvSpPr/>
+          <p:nvPr/>
+        </p:nvSpPr>
+        <p:spPr>
+          <a:xfrm>
+            <a:off x="0" y="0"/>
+            <a:ext cx="12191695" cy="6858000"/>
+          </a:xfrm>
+          <a:prstGeom prst="rect">
+            <a:avLst/>
+          </a:prstGeom>
+          <a:solidFill>
+            <a:srgbClr val="F8FAFC"/>
+          </a:solidFill>
+          <a:ln>
+            <a:noFill/>
+          </a:ln>
+        </p:spPr>
+        <p:style>
+          <a:lnRef idx="1">
+            <a:schemeClr val="accent1"/>
+          </a:lnRef>
+          <a:fillRef idx="3">
+            <a:schemeClr val="accent1"/>
+          </a:fillRef>
+          <a:effectRef idx="2">
+            <a:schemeClr val="accent1"/>
+          </a:effectRef>
+          <a:fontRef idx="minor">
+            <a:schemeClr val="lt1"/>
+          </a:fontRef>
+        </p:style>
+        <p:txBody>
+          <a:bodyPr rtlCol="0" anchor="ctr"/>
+          <a:lstStyle/>
+          <a:p>
+            <a:pPr algn="ctr"/>
+          </a:p>
+        </p:txBody>
+      </p:sp>
+      <p:sp>
+        <p:nvSpPr>
+          <p:cNvPr id="3" name="Rectangle 2"/>
+          <p:cNvSpPr/>
+          <p:nvPr/>
+        </p:nvSpPr>
+        <p:spPr>
+          <a:xfrm>
+            <a:off x="731520" y="365760"/>
+            <a:ext cx="10728655" cy="1005840"/>
+          </a:xfrm>
+          <a:prstGeom prst="rect">
+            <a:avLst/>
+          </a:prstGeom>
+          <a:solidFill>
+            <a:srgbClr val="FFFFFF"/>
+          </a:solidFill>
+          <a:ln w="12700">
+            <a:solidFill>
+              <a:srgbClr val="E2E8F0"/>
+            </a:solidFill>
+          </a:ln>
+        </p:spPr>
+        <p:style>
+          <a:lnRef idx="1">
+            <a:schemeClr val="accent1"/>
+          </a:lnRef>
+          <a:fillRef idx="3">
+            <a:schemeClr val="accent1"/>
+          </a:fillRef>
+          <a:effectRef idx="2">
+            <a:schemeClr val="accent1"/>
+          </a:effectRef>
+          <a:fontRef idx="minor">
+            <a:schemeClr val="lt1"/>
+          </a:fontRef>
+        </p:style>
+        <p:txBody>
+          <a:bodyPr rtlCol="0" anchor="ctr" wrap="square" lIns="228600" tIns="109728" rIns="228600" bIns="91440"/>
+          <a:lstStyle/>
+          <a:p>
+            <a:pPr algn="ctr">
+              <a:defRPr sz="1100" b="1">
+                <a:solidFill>
+                  <a:srgbClr val="2563EB"/>
+                </a:solidFill>
+                <a:latin typeface="Calibri"/>
+              </a:defRPr>
+            </a:pPr>
+            <a:r>
+              <a:t>PHASE 3: SOFTWARE ENGINEERING &amp; QA   •   PRESENTER: TRISTAN DAVE M. PLAZA (MOBILE UX LEAD &amp; COURIER 1)</a:t>
+            </a:r>
+          </a:p>
+          <a:p>
+            <a:pPr>
+              <a:spcBef>
+                <a:spcPts val="300"/>
+              </a:spcBef>
+              <a:defRPr sz="2000" b="1">
+                <a:solidFill>
+                  <a:srgbClr val="0F172A"/>
+                </a:solidFill>
+                <a:latin typeface="Arial"/>
+              </a:defRPr>
+            </a:pPr>
+            <a:r>
+              <a:t>Engineering Integrity: Architecture, RBAC &amp; Test Evidence</a:t>
             </a:r>
           </a:p>
         </p:txBody>
@@ -3783,7 +4908,7 @@
               </a:defRPr>
             </a:pPr>
             <a:r>
-              <a:t>🌟  What is LaundryCare?</a:t>
+              <a:t>🏗️  Modular System Architecture</a:t>
             </a:r>
           </a:p>
           <a:p>
@@ -3802,7 +4927,7 @@
               </a:defRPr>
             </a:pPr>
             <a:r>
-              <a:t>•  Core Purpose: A full-stack, cloud-deployed web ERP and doorstep logistics system engineered specifically for Barangay Base Camp, Maramag, Bukidnon.</a:t>
+              <a:t>•  Backend Framework: Python 3 + Flask using 6 decoupled domain Blueprints (Customer, Order, Pickup, Delivery, Payment, Portal).</a:t>
             </a:r>
           </a:p>
           <a:p>
@@ -3821,7 +4946,7 @@
               </a:defRPr>
             </a:pPr>
             <a:r>
-              <a:t>•  Digital Transformation: Replaces chaotic manual pen-and-paper booking with an automated, transparent, and paperless operational pipeline.</a:t>
+              <a:t>•  Merge Conflict Prevention: Team members worked on separate controllers concurrently without Git collisions.</a:t>
             </a:r>
           </a:p>
           <a:p>
@@ -3840,7 +4965,7 @@
               </a:defRPr>
             </a:pPr>
             <a:r>
-              <a:t>•  Community Context: Tailored for Base Camp households, dormitories, and busy families who lack time or washing equipment.</a:t>
+              <a:t>•  Database Architecture: SQLite 3 with enforced foreign keys (PRAGMA foreign_keys = ON) and automatic cold-start migrations.</a:t>
             </a:r>
           </a:p>
           <a:p>
@@ -3859,7 +4984,7 @@
               </a:defRPr>
             </a:pPr>
             <a:r>
-              <a:t>•  End-to-End Scope: Integrates customers, store cashiers, laundry machine operators, and motorcycle couriers into one centralized platform.</a:t>
+              <a:t>•  Dual-Mode Error Handler: Returns JSON for AJAX fetch calls and branded HTML for browser navigation (zero stack trace leakage).</a:t>
             </a:r>
           </a:p>
           <a:p>
@@ -3878,7 +5003,7 @@
               </a:defRPr>
             </a:pPr>
             <a:r>
-              <a:t>•  Cloud Availability: Deployed live on Render PaaS (Linux Gunicorn WSGI) with local offline hot standby.</a:t>
+              <a:t>•  Role-Based Access Control: Decorator checks session roles (Admin, Staff, Rider) preventing privilege escalation.</a:t>
             </a:r>
           </a:p>
         </p:txBody>
@@ -3936,7 +5061,7 @@
               </a:defRPr>
             </a:pPr>
             <a:r>
-              <a:t>🏛️  The 3 Core Operational Pillars</a:t>
+              <a:t>🛡️  Adversarial Security &amp; Test Evidence</a:t>
             </a:r>
           </a:p>
           <a:p>
@@ -3955,7 +5080,7 @@
               </a:defRPr>
             </a:pPr>
             <a:r>
-              <a:t>•  1. Public Customer Portal (Zero Login): 60-second doorstep pickup booking and real-time 5-stage tracking with GCash payment references.</a:t>
+              <a:t>•  Stored XSS Sanitization (BUG-001): Regex-based tag stripper (strip_html_tags()) purges &lt;script&gt; and &lt;style&gt; tags before database storage.</a:t>
             </a:r>
           </a:p>
           <a:p>
@@ -3974,7 +5099,7 @@
               </a:defRPr>
             </a:pPr>
             <a:r>
-              <a:t>•  2. Centralized Store Operations: Digital scale intake, automated per-kilo pricing, dynamic loyalty tiering, and wash plant machine telemetry.</a:t>
+              <a:t>•  Physical Capacity Ceiling (BUG-002): Caps single order weight at 150.0 kg. Oversized loads return HTTP 422 commercial warning.</a:t>
             </a:r>
           </a:p>
           <a:p>
@@ -3993,7 +5118,7 @@
               </a:defRPr>
             </a:pPr>
             <a:r>
-              <a:t>•  3. Sector-Based Motorcycle Fleet: 100% motorcycle courier circuits across Base Camp with 1-tap GPS routing and touch signature proof-of-delivery.</a:t>
+              <a:t>•  Historical Date Prevention (BUG-003): Dynamic min date attribute and server-side checks block bookings in the past.</a:t>
             </a:r>
           </a:p>
           <a:p>
@@ -4012,7 +5137,26 @@
               </a:defRPr>
             </a:pPr>
             <a:r>
-              <a:t>•  4. Software Quality Standards: Backed by 78 / 78 passing automated unit, integration, and adversarial tests (100% green suite).</a:t>
+              <a:t>•  Modal Freezing Resolution (BUG-004): Universal Escape key event handler cleanly dismisses dialogs across all browsers.</a:t>
+            </a:r>
+          </a:p>
+          <a:p>
+            <a:pPr>
+              <a:spcBef>
+                <a:spcPts val="400"/>
+              </a:spcBef>
+              <a:spcAft>
+                <a:spcPts val="400"/>
+              </a:spcAft>
+              <a:defRPr sz="1200">
+                <a:solidFill>
+                  <a:srgbClr val="475569"/>
+                </a:solidFill>
+                <a:latin typeface="Calibri"/>
+              </a:defRPr>
+            </a:pPr>
+            <a:r>
+              <a:t>•  79 / 79 Passing Pytest Tests: 100% green suite validating RBAC, arithmetic precision, and adversarial boundary limits.</a:t>
             </a:r>
           </a:p>
         </p:txBody>
@@ -4025,7 +5169,7 @@
 </p:sld>
 </file>
 
-<file path=ppt/slides/slide3.xml><?xml version="1.0" encoding="utf-8"?>
+<file path=ppt/slides/slide5.xml><?xml version="1.0" encoding="utf-8"?>
 <p:sld xmlns:a="http://schemas.openxmlformats.org/drawingml/2006/main" xmlns:p="http://schemas.openxmlformats.org/presentationml/2006/main" xmlns:r="http://schemas.openxmlformats.org/officeDocument/2006/relationships">
   <p:cSld>
     <p:spTree>
@@ -4128,7 +5272,7 @@
               </a:defRPr>
             </a:pPr>
             <a:r>
-              <a:t>PHASE 1: PROBLEM DEFINITION   •   PRESENTER: HAZIL ENOC (STORE CASHIER &amp; CRM LEAD)</a:t>
+              <a:t>PHASE 4: OPERATIONS &amp; LIVE DEMONSTRATION   •   PRESENTER: MARVIN OCLARINO (FINANCIAL SETTLEMENT LEAD &amp; COURIER 2)</a:t>
             </a:r>
           </a:p>
           <a:p>
@@ -4144,1571 +5288,7 @@
               </a:defRPr>
             </a:pPr>
             <a:r>
-              <a:t>The Challenge: Bottlenecks in Traditional Laundry Shops</a:t>
-            </a:r>
-          </a:p>
-        </p:txBody>
-      </p:sp>
-      <p:sp>
-        <p:nvSpPr>
-          <p:cNvPr id="4" name="Rounded Rectangle 3"/>
-          <p:cNvSpPr/>
-          <p:nvPr/>
-        </p:nvSpPr>
-        <p:spPr>
-          <a:xfrm>
-            <a:off x="731520" y="1600200"/>
-            <a:ext cx="2542032" cy="4663440"/>
-          </a:xfrm>
-          <a:prstGeom prst="roundRect">
-            <a:avLst/>
-          </a:prstGeom>
-          <a:solidFill>
-            <a:srgbClr val="FFFFFF"/>
-          </a:solidFill>
-          <a:ln w="19050">
-            <a:solidFill>
-              <a:srgbClr val="E2E8F0"/>
-            </a:solidFill>
-          </a:ln>
-        </p:spPr>
-        <p:style>
-          <a:lnRef idx="1">
-            <a:schemeClr val="accent1"/>
-          </a:lnRef>
-          <a:fillRef idx="3">
-            <a:schemeClr val="accent1"/>
-          </a:fillRef>
-          <a:effectRef idx="2">
-            <a:schemeClr val="accent1"/>
-          </a:effectRef>
-          <a:fontRef idx="minor">
-            <a:schemeClr val="lt1"/>
-          </a:fontRef>
-        </p:style>
-        <p:txBody>
-          <a:bodyPr rtlCol="0" anchor="ctr" wrap="square" lIns="228600" tIns="182880" rIns="228600" bIns="182880"/>
-          <a:lstStyle/>
-          <a:p>
-            <a:pPr algn="ctr">
-              <a:spcAft>
-                <a:spcPts val="800"/>
-              </a:spcAft>
-              <a:defRPr sz="1500" b="1">
-                <a:solidFill>
-                  <a:srgbClr val="1E3A8A"/>
-                </a:solidFill>
-                <a:latin typeface="Arial"/>
-              </a:defRPr>
-            </a:pPr>
-            <a:r>
-              <a:t>🏷️  Lost Paper Slips &amp; Tags</a:t>
-            </a:r>
-          </a:p>
-          <a:p>
-            <a:pPr>
-              <a:spcBef>
-                <a:spcPts val="400"/>
-              </a:spcBef>
-              <a:spcAft>
-                <a:spcPts val="400"/>
-              </a:spcAft>
-              <a:defRPr sz="1200">
-                <a:solidFill>
-                  <a:srgbClr val="475569"/>
-                </a:solidFill>
-                <a:latin typeface="Calibri"/>
-              </a:defRPr>
-            </a:pPr>
-            <a:r>
-              <a:t>•  Physical paper receipts get torn, wet, or lost on the shop floor.</a:t>
-            </a:r>
-          </a:p>
-          <a:p>
-            <a:pPr>
-              <a:spcBef>
-                <a:spcPts val="400"/>
-              </a:spcBef>
-              <a:spcAft>
-                <a:spcPts val="400"/>
-              </a:spcAft>
-              <a:defRPr sz="1200">
-                <a:solidFill>
-                  <a:srgbClr val="475569"/>
-                </a:solidFill>
-                <a:latin typeface="Calibri"/>
-              </a:defRPr>
-            </a:pPr>
-            <a:r>
-              <a:t>•  Manual identification tags lead to misplaced garments and bag mix-ups.</a:t>
-            </a:r>
-          </a:p>
-          <a:p>
-            <a:pPr>
-              <a:spcBef>
-                <a:spcPts val="400"/>
-              </a:spcBef>
-              <a:spcAft>
-                <a:spcPts val="400"/>
-              </a:spcAft>
-              <a:defRPr sz="1200">
-                <a:solidFill>
-                  <a:srgbClr val="475569"/>
-                </a:solidFill>
-                <a:latin typeface="Calibri"/>
-              </a:defRPr>
-            </a:pPr>
-            <a:r>
-              <a:t>•  Zero permanent digital audit trail for customer service histories.</a:t>
-            </a:r>
-          </a:p>
-        </p:txBody>
-      </p:sp>
-      <p:sp>
-        <p:nvSpPr>
-          <p:cNvPr id="5" name="Rounded Rectangle 4"/>
-          <p:cNvSpPr/>
-          <p:nvPr/>
-        </p:nvSpPr>
-        <p:spPr>
-          <a:xfrm>
-            <a:off x="3456432" y="1600200"/>
-            <a:ext cx="2542032" cy="4663440"/>
-          </a:xfrm>
-          <a:prstGeom prst="roundRect">
-            <a:avLst/>
-          </a:prstGeom>
-          <a:solidFill>
-            <a:srgbClr val="FFFFFF"/>
-          </a:solidFill>
-          <a:ln w="19050">
-            <a:solidFill>
-              <a:srgbClr val="E2E8F0"/>
-            </a:solidFill>
-          </a:ln>
-        </p:spPr>
-        <p:style>
-          <a:lnRef idx="1">
-            <a:schemeClr val="accent1"/>
-          </a:lnRef>
-          <a:fillRef idx="3">
-            <a:schemeClr val="accent1"/>
-          </a:fillRef>
-          <a:effectRef idx="2">
-            <a:schemeClr val="accent1"/>
-          </a:effectRef>
-          <a:fontRef idx="minor">
-            <a:schemeClr val="lt1"/>
-          </a:fontRef>
-        </p:style>
-        <p:txBody>
-          <a:bodyPr rtlCol="0" anchor="ctr" wrap="square" lIns="228600" tIns="182880" rIns="228600" bIns="182880"/>
-          <a:lstStyle/>
-          <a:p>
-            <a:pPr algn="ctr">
-              <a:spcAft>
-                <a:spcPts val="800"/>
-              </a:spcAft>
-              <a:defRPr sz="1500" b="1">
-                <a:solidFill>
-                  <a:srgbClr val="1E3A8A"/>
-                </a:solidFill>
-                <a:latin typeface="Arial"/>
-              </a:defRPr>
-            </a:pPr>
-            <a:r>
-              <a:t>👀  Customer Blindspots</a:t>
-            </a:r>
-          </a:p>
-          <a:p>
-            <a:pPr>
-              <a:spcBef>
-                <a:spcPts val="400"/>
-              </a:spcBef>
-              <a:spcAft>
-                <a:spcPts val="400"/>
-              </a:spcAft>
-              <a:defRPr sz="1200">
-                <a:solidFill>
-                  <a:srgbClr val="475569"/>
-                </a:solidFill>
-                <a:latin typeface="Calibri"/>
-              </a:defRPr>
-            </a:pPr>
-            <a:r>
-              <a:t>•  Clients have zero visibility into washing and drying stages.</a:t>
-            </a:r>
-          </a:p>
-          <a:p>
-            <a:pPr>
-              <a:spcBef>
-                <a:spcPts val="400"/>
-              </a:spcBef>
-              <a:spcAft>
-                <a:spcPts val="400"/>
-              </a:spcAft>
-              <a:defRPr sz="1200">
-                <a:solidFill>
-                  <a:srgbClr val="475569"/>
-                </a:solidFill>
-                <a:latin typeface="Calibri"/>
-              </a:defRPr>
-            </a:pPr>
-            <a:r>
-              <a:t>•  Students and busy families repeatedly call staff asking if laundry is ready.</a:t>
-            </a:r>
-          </a:p>
-          <a:p>
-            <a:pPr>
-              <a:spcBef>
-                <a:spcPts val="400"/>
-              </a:spcBef>
-              <a:spcAft>
-                <a:spcPts val="400"/>
-              </a:spcAft>
-              <a:defRPr sz="1200">
-                <a:solidFill>
-                  <a:srgbClr val="475569"/>
-                </a:solidFill>
-                <a:latin typeface="Calibri"/>
-              </a:defRPr>
-            </a:pPr>
-            <a:r>
-              <a:t>•  No digital notifications when riders are en route for collection.</a:t>
-            </a:r>
-          </a:p>
-        </p:txBody>
-      </p:sp>
-      <p:sp>
-        <p:nvSpPr>
-          <p:cNvPr id="6" name="Rounded Rectangle 5"/>
-          <p:cNvSpPr/>
-          <p:nvPr/>
-        </p:nvSpPr>
-        <p:spPr>
-          <a:xfrm>
-            <a:off x="6181344" y="1600200"/>
-            <a:ext cx="2542032" cy="4663440"/>
-          </a:xfrm>
-          <a:prstGeom prst="roundRect">
-            <a:avLst/>
-          </a:prstGeom>
-          <a:solidFill>
-            <a:srgbClr val="FFFFFF"/>
-          </a:solidFill>
-          <a:ln w="19050">
-            <a:solidFill>
-              <a:srgbClr val="E2E8F0"/>
-            </a:solidFill>
-          </a:ln>
-        </p:spPr>
-        <p:style>
-          <a:lnRef idx="1">
-            <a:schemeClr val="accent1"/>
-          </a:lnRef>
-          <a:fillRef idx="3">
-            <a:schemeClr val="accent1"/>
-          </a:fillRef>
-          <a:effectRef idx="2">
-            <a:schemeClr val="accent1"/>
-          </a:effectRef>
-          <a:fontRef idx="minor">
-            <a:schemeClr val="lt1"/>
-          </a:fontRef>
-        </p:style>
-        <p:txBody>
-          <a:bodyPr rtlCol="0" anchor="ctr" wrap="square" lIns="228600" tIns="182880" rIns="228600" bIns="182880"/>
-          <a:lstStyle/>
-          <a:p>
-            <a:pPr algn="ctr">
-              <a:spcAft>
-                <a:spcPts val="800"/>
-              </a:spcAft>
-              <a:defRPr sz="1500" b="1">
-                <a:solidFill>
-                  <a:srgbClr val="1E3A8A"/>
-                </a:solidFill>
-                <a:latin typeface="Arial"/>
-              </a:defRPr>
-            </a:pPr>
-            <a:r>
-              <a:t>🛵  Uncoordinated Couriers</a:t>
-            </a:r>
-          </a:p>
-          <a:p>
-            <a:pPr>
-              <a:spcBef>
-                <a:spcPts val="400"/>
-              </a:spcBef>
-              <a:spcAft>
-                <a:spcPts val="400"/>
-              </a:spcAft>
-              <a:defRPr sz="1200">
-                <a:solidFill>
-                  <a:srgbClr val="475569"/>
-                </a:solidFill>
-                <a:latin typeface="Calibri"/>
-              </a:defRPr>
-            </a:pPr>
-            <a:r>
-              <a:t>•  Riders receive unstructured phone calls with unclear landmarks.</a:t>
-            </a:r>
-          </a:p>
-          <a:p>
-            <a:pPr>
-              <a:spcBef>
-                <a:spcPts val="400"/>
-              </a:spcBef>
-              <a:spcAft>
-                <a:spcPts val="400"/>
-              </a:spcAft>
-              <a:defRPr sz="1200">
-                <a:solidFill>
-                  <a:srgbClr val="475569"/>
-                </a:solidFill>
-                <a:latin typeface="Calibri"/>
-              </a:defRPr>
-            </a:pPr>
-            <a:r>
-              <a:t>•  No sector planning leads to overlapping routes and wasted fuel.</a:t>
-            </a:r>
-          </a:p>
-          <a:p>
-            <a:pPr>
-              <a:spcBef>
-                <a:spcPts val="400"/>
-              </a:spcBef>
-              <a:spcAft>
-                <a:spcPts val="400"/>
-              </a:spcAft>
-              <a:defRPr sz="1200">
-                <a:solidFill>
-                  <a:srgbClr val="475569"/>
-                </a:solidFill>
-                <a:latin typeface="Calibri"/>
-              </a:defRPr>
-            </a:pPr>
-            <a:r>
-              <a:t>•  Peak intake hours overwhelm couriers without scheduling density checks.</a:t>
-            </a:r>
-          </a:p>
-        </p:txBody>
-      </p:sp>
-      <p:sp>
-        <p:nvSpPr>
-          <p:cNvPr id="7" name="Rounded Rectangle 6"/>
-          <p:cNvSpPr/>
-          <p:nvPr/>
-        </p:nvSpPr>
-        <p:spPr>
-          <a:xfrm>
-            <a:off x="8906256" y="1600200"/>
-            <a:ext cx="2542032" cy="4663440"/>
-          </a:xfrm>
-          <a:prstGeom prst="roundRect">
-            <a:avLst/>
-          </a:prstGeom>
-          <a:solidFill>
-            <a:srgbClr val="FFFFFF"/>
-          </a:solidFill>
-          <a:ln w="19050">
-            <a:solidFill>
-              <a:srgbClr val="E2E8F0"/>
-            </a:solidFill>
-          </a:ln>
-        </p:spPr>
-        <p:style>
-          <a:lnRef idx="1">
-            <a:schemeClr val="accent1"/>
-          </a:lnRef>
-          <a:fillRef idx="3">
-            <a:schemeClr val="accent1"/>
-          </a:fillRef>
-          <a:effectRef idx="2">
-            <a:schemeClr val="accent1"/>
-          </a:effectRef>
-          <a:fontRef idx="minor">
-            <a:schemeClr val="lt1"/>
-          </a:fontRef>
-        </p:style>
-        <p:txBody>
-          <a:bodyPr rtlCol="0" anchor="ctr" wrap="square" lIns="228600" tIns="182880" rIns="228600" bIns="182880"/>
-          <a:lstStyle/>
-          <a:p>
-            <a:pPr algn="ctr">
-              <a:spcAft>
-                <a:spcPts val="800"/>
-              </a:spcAft>
-              <a:defRPr sz="1500" b="1">
-                <a:solidFill>
-                  <a:srgbClr val="1E3A8A"/>
-                </a:solidFill>
-                <a:latin typeface="Arial"/>
-              </a:defRPr>
-            </a:pPr>
-            <a:r>
-              <a:t>🧮  Doorstep Math Errors</a:t>
-            </a:r>
-          </a:p>
-          <a:p>
-            <a:pPr>
-              <a:spcBef>
-                <a:spcPts val="400"/>
-              </a:spcBef>
-              <a:spcAft>
-                <a:spcPts val="400"/>
-              </a:spcAft>
-              <a:defRPr sz="1200">
-                <a:solidFill>
-                  <a:srgbClr val="475569"/>
-                </a:solidFill>
-                <a:latin typeface="Calibri"/>
-              </a:defRPr>
-            </a:pPr>
-            <a:r>
-              <a:t>•  Couriers mentally compute per-kilogram rates and cash change on the road.</a:t>
-            </a:r>
-          </a:p>
-          <a:p>
-            <a:pPr>
-              <a:spcBef>
-                <a:spcPts val="400"/>
-              </a:spcBef>
-              <a:spcAft>
-                <a:spcPts val="400"/>
-              </a:spcAft>
-              <a:defRPr sz="1200">
-                <a:solidFill>
-                  <a:srgbClr val="475569"/>
-                </a:solidFill>
-                <a:latin typeface="Calibri"/>
-              </a:defRPr>
-            </a:pPr>
-            <a:r>
-              <a:t>•  Cashier end-of-day reconciliation deficits from arithmetic mistakes.</a:t>
-            </a:r>
-          </a:p>
-          <a:p>
-            <a:pPr>
-              <a:spcBef>
-                <a:spcPts val="400"/>
-              </a:spcBef>
-              <a:spcAft>
-                <a:spcPts val="400"/>
-              </a:spcAft>
-              <a:defRPr sz="1200">
-                <a:solidFill>
-                  <a:srgbClr val="475569"/>
-                </a:solidFill>
-                <a:latin typeface="Calibri"/>
-              </a:defRPr>
-            </a:pPr>
-            <a:r>
-              <a:t>•  Lack of digital Proof of Delivery (POD) signatures causes disputes.</a:t>
-            </a:r>
-          </a:p>
-        </p:txBody>
-      </p:sp>
-    </p:spTree>
-  </p:cSld>
-  <p:clrMapOvr>
-    <a:masterClrMapping/>
-  </p:clrMapOvr>
-</p:sld>
-</file>
-
-<file path=ppt/slides/slide4.xml><?xml version="1.0" encoding="utf-8"?>
-<p:sld xmlns:a="http://schemas.openxmlformats.org/drawingml/2006/main" xmlns:p="http://schemas.openxmlformats.org/presentationml/2006/main" xmlns:r="http://schemas.openxmlformats.org/officeDocument/2006/relationships">
-  <p:cSld>
-    <p:spTree>
-      <p:nvGrpSpPr>
-        <p:cNvPr id="1" name=""/>
-        <p:cNvGrpSpPr/>
-        <p:nvPr/>
-      </p:nvGrpSpPr>
-      <p:grpSpPr/>
-      <p:sp>
-        <p:nvSpPr>
-          <p:cNvPr id="2" name="Rectangle 1"/>
-          <p:cNvSpPr/>
-          <p:nvPr/>
-        </p:nvSpPr>
-        <p:spPr>
-          <a:xfrm>
-            <a:off x="0" y="0"/>
-            <a:ext cx="12191695" cy="6858000"/>
-          </a:xfrm>
-          <a:prstGeom prst="rect">
-            <a:avLst/>
-          </a:prstGeom>
-          <a:solidFill>
-            <a:srgbClr val="F8FAFC"/>
-          </a:solidFill>
-          <a:ln>
-            <a:noFill/>
-          </a:ln>
-        </p:spPr>
-        <p:style>
-          <a:lnRef idx="1">
-            <a:schemeClr val="accent1"/>
-          </a:lnRef>
-          <a:fillRef idx="3">
-            <a:schemeClr val="accent1"/>
-          </a:fillRef>
-          <a:effectRef idx="2">
-            <a:schemeClr val="accent1"/>
-          </a:effectRef>
-          <a:fontRef idx="minor">
-            <a:schemeClr val="lt1"/>
-          </a:fontRef>
-        </p:style>
-        <p:txBody>
-          <a:bodyPr rtlCol="0" anchor="ctr"/>
-          <a:lstStyle/>
-          <a:p>
-            <a:pPr algn="ctr"/>
-          </a:p>
-        </p:txBody>
-      </p:sp>
-      <p:sp>
-        <p:nvSpPr>
-          <p:cNvPr id="3" name="Rectangle 2"/>
-          <p:cNvSpPr/>
-          <p:nvPr/>
-        </p:nvSpPr>
-        <p:spPr>
-          <a:xfrm>
-            <a:off x="731520" y="365760"/>
-            <a:ext cx="10728655" cy="1005840"/>
-          </a:xfrm>
-          <a:prstGeom prst="rect">
-            <a:avLst/>
-          </a:prstGeom>
-          <a:solidFill>
-            <a:srgbClr val="FFFFFF"/>
-          </a:solidFill>
-          <a:ln w="12700">
-            <a:solidFill>
-              <a:srgbClr val="E2E8F0"/>
-            </a:solidFill>
-          </a:ln>
-        </p:spPr>
-        <p:style>
-          <a:lnRef idx="1">
-            <a:schemeClr val="accent1"/>
-          </a:lnRef>
-          <a:fillRef idx="3">
-            <a:schemeClr val="accent1"/>
-          </a:fillRef>
-          <a:effectRef idx="2">
-            <a:schemeClr val="accent1"/>
-          </a:effectRef>
-          <a:fontRef idx="minor">
-            <a:schemeClr val="lt1"/>
-          </a:fontRef>
-        </p:style>
-        <p:txBody>
-          <a:bodyPr rtlCol="0" anchor="ctr" wrap="square" lIns="228600" tIns="109728" rIns="228600" bIns="91440"/>
-          <a:lstStyle/>
-          <a:p>
-            <a:pPr algn="ctr">
-              <a:defRPr sz="1100" b="1">
-                <a:solidFill>
-                  <a:srgbClr val="2563EB"/>
-                </a:solidFill>
-                <a:latin typeface="Calibri"/>
-              </a:defRPr>
-            </a:pPr>
-            <a:r>
-              <a:t>PHASE 2: SOLUTION ARCHITECTURE   •   PRESENTER: MARK EPHRAIM NICOR (LAUNDRY OPERATOR &amp; COURIER 3)</a:t>
-            </a:r>
-          </a:p>
-          <a:p>
-            <a:pPr>
-              <a:spcBef>
-                <a:spcPts val="300"/>
-              </a:spcBef>
-              <a:defRPr sz="2000" b="1">
-                <a:solidFill>
-                  <a:srgbClr val="0F172A"/>
-                </a:solidFill>
-                <a:latin typeface="Arial"/>
-              </a:defRPr>
-            </a:pPr>
-            <a:r>
-              <a:t>The LaundryCare Platform: 3 Unified Portals</a:t>
-            </a:r>
-          </a:p>
-        </p:txBody>
-      </p:sp>
-      <p:sp>
-        <p:nvSpPr>
-          <p:cNvPr id="4" name="Rounded Rectangle 3"/>
-          <p:cNvSpPr/>
-          <p:nvPr/>
-        </p:nvSpPr>
-        <p:spPr>
-          <a:xfrm>
-            <a:off x="731520" y="1600200"/>
-            <a:ext cx="3447288" cy="4663440"/>
-          </a:xfrm>
-          <a:prstGeom prst="roundRect">
-            <a:avLst/>
-          </a:prstGeom>
-          <a:solidFill>
-            <a:srgbClr val="FFFFFF"/>
-          </a:solidFill>
-          <a:ln w="19050">
-            <a:solidFill>
-              <a:srgbClr val="E2E8F0"/>
-            </a:solidFill>
-          </a:ln>
-        </p:spPr>
-        <p:style>
-          <a:lnRef idx="1">
-            <a:schemeClr val="accent1"/>
-          </a:lnRef>
-          <a:fillRef idx="3">
-            <a:schemeClr val="accent1"/>
-          </a:fillRef>
-          <a:effectRef idx="2">
-            <a:schemeClr val="accent1"/>
-          </a:effectRef>
-          <a:fontRef idx="minor">
-            <a:schemeClr val="lt1"/>
-          </a:fontRef>
-        </p:style>
-        <p:txBody>
-          <a:bodyPr rtlCol="0" anchor="ctr" wrap="square" lIns="228600" tIns="182880" rIns="228600" bIns="182880"/>
-          <a:lstStyle/>
-          <a:p>
-            <a:pPr algn="ctr">
-              <a:spcAft>
-                <a:spcPts val="800"/>
-              </a:spcAft>
-              <a:defRPr sz="1500" b="1">
-                <a:solidFill>
-                  <a:srgbClr val="1E3A8A"/>
-                </a:solidFill>
-                <a:latin typeface="Arial"/>
-              </a:defRPr>
-            </a:pPr>
-            <a:r>
-              <a:t>📱  Public Customer Portal</a:t>
-            </a:r>
-          </a:p>
-          <a:p>
-            <a:pPr>
-              <a:spcBef>
-                <a:spcPts val="400"/>
-              </a:spcBef>
-              <a:spcAft>
-                <a:spcPts val="400"/>
-              </a:spcAft>
-              <a:defRPr sz="1200">
-                <a:solidFill>
-                  <a:srgbClr val="475569"/>
-                </a:solidFill>
-                <a:latin typeface="Calibri"/>
-              </a:defRPr>
-            </a:pPr>
-            <a:r>
-              <a:t>•  Zero Login Required: Frictionless access for dormitory students and residents.</a:t>
-            </a:r>
-          </a:p>
-          <a:p>
-            <a:pPr>
-              <a:spcBef>
-                <a:spcPts val="400"/>
-              </a:spcBef>
-              <a:spcAft>
-                <a:spcPts val="400"/>
-              </a:spcAft>
-              <a:defRPr sz="1200">
-                <a:solidFill>
-                  <a:srgbClr val="475569"/>
-                </a:solidFill>
-                <a:latin typeface="Calibri"/>
-              </a:defRPr>
-            </a:pPr>
-            <a:r>
-              <a:t>•  60-Second Online Booking (/book-pickup): Sector-based pickup scheduling.</a:t>
-            </a:r>
-          </a:p>
-          <a:p>
-            <a:pPr>
-              <a:spcBef>
-                <a:spcPts val="400"/>
-              </a:spcBef>
-              <a:spcAft>
-                <a:spcPts val="400"/>
-              </a:spcAft>
-              <a:defRPr sz="1200">
-                <a:solidFill>
-                  <a:srgbClr val="475569"/>
-                </a:solidFill>
-                <a:latin typeface="Calibri"/>
-              </a:defRPr>
-            </a:pPr>
-            <a:r>
-              <a:t>•  Live Real-Time Tracker (/track): 5-step progress bar from intake to doorstep drop-off.</a:t>
-            </a:r>
-          </a:p>
-          <a:p>
-            <a:pPr>
-              <a:spcBef>
-                <a:spcPts val="400"/>
-              </a:spcBef>
-              <a:spcAft>
-                <a:spcPts val="400"/>
-              </a:spcAft>
-              <a:defRPr sz="1200">
-                <a:solidFill>
-                  <a:srgbClr val="475569"/>
-                </a:solidFill>
-                <a:latin typeface="Calibri"/>
-              </a:defRPr>
-            </a:pPr>
-            <a:r>
-              <a:t>•  Transparent Payments: Electronic GCash/Maya reference modal.</a:t>
-            </a:r>
-          </a:p>
-        </p:txBody>
-      </p:sp>
-      <p:sp>
-        <p:nvSpPr>
-          <p:cNvPr id="5" name="Rounded Rectangle 4"/>
-          <p:cNvSpPr/>
-          <p:nvPr/>
-        </p:nvSpPr>
-        <p:spPr>
-          <a:xfrm>
-            <a:off x="4361688" y="1600200"/>
-            <a:ext cx="3447288" cy="4663440"/>
-          </a:xfrm>
-          <a:prstGeom prst="roundRect">
-            <a:avLst/>
-          </a:prstGeom>
-          <a:solidFill>
-            <a:srgbClr val="FFFFFF"/>
-          </a:solidFill>
-          <a:ln w="19050">
-            <a:solidFill>
-              <a:srgbClr val="E2E8F0"/>
-            </a:solidFill>
-          </a:ln>
-        </p:spPr>
-        <p:style>
-          <a:lnRef idx="1">
-            <a:schemeClr val="accent1"/>
-          </a:lnRef>
-          <a:fillRef idx="3">
-            <a:schemeClr val="accent1"/>
-          </a:fillRef>
-          <a:effectRef idx="2">
-            <a:schemeClr val="accent1"/>
-          </a:effectRef>
-          <a:fontRef idx="minor">
-            <a:schemeClr val="lt1"/>
-          </a:fontRef>
-        </p:style>
-        <p:txBody>
-          <a:bodyPr rtlCol="0" anchor="ctr" wrap="square" lIns="228600" tIns="182880" rIns="228600" bIns="182880"/>
-          <a:lstStyle/>
-          <a:p>
-            <a:pPr algn="ctr">
-              <a:spcAft>
-                <a:spcPts val="800"/>
-              </a:spcAft>
-              <a:defRPr sz="1500" b="1">
-                <a:solidFill>
-                  <a:srgbClr val="1E3A8A"/>
-                </a:solidFill>
-                <a:latin typeface="Arial"/>
-              </a:defRPr>
-            </a:pPr>
-            <a:r>
-              <a:t>🧺  Cashier &amp; Wash Operations</a:t>
-            </a:r>
-          </a:p>
-          <a:p>
-            <a:pPr>
-              <a:spcBef>
-                <a:spcPts val="400"/>
-              </a:spcBef>
-              <a:spcAft>
-                <a:spcPts val="400"/>
-              </a:spcAft>
-              <a:defRPr sz="1200">
-                <a:solidFill>
-                  <a:srgbClr val="475569"/>
-                </a:solidFill>
-                <a:latin typeface="Calibri"/>
-              </a:defRPr>
-            </a:pPr>
-            <a:r>
-              <a:t>•  Customer CRM Directory (/customers-page): Lifetime spend &amp; loyalty tier tracking.</a:t>
-            </a:r>
-          </a:p>
-          <a:p>
-            <a:pPr>
-              <a:spcBef>
-                <a:spcPts val="400"/>
-              </a:spcBef>
-              <a:spcAft>
-                <a:spcPts val="400"/>
-              </a:spcAft>
-              <a:defRPr sz="1200">
-                <a:solidFill>
-                  <a:srgbClr val="475569"/>
-                </a:solidFill>
-                <a:latin typeface="Calibri"/>
-              </a:defRPr>
-            </a:pPr>
-            <a:r>
-              <a:t>•  Digital Scale Intake (/laundry-orders-page): Auto-pricing calculation (Weight x Rate).</a:t>
-            </a:r>
-          </a:p>
-          <a:p>
-            <a:pPr>
-              <a:spcBef>
-                <a:spcPts val="400"/>
-              </a:spcBef>
-              <a:spcAft>
-                <a:spcPts val="400"/>
-              </a:spcAft>
-              <a:defRPr sz="1200">
-                <a:solidFill>
-                  <a:srgbClr val="475569"/>
-                </a:solidFill>
-                <a:latin typeface="Calibri"/>
-              </a:defRPr>
-            </a:pPr>
-            <a:r>
-              <a:t>•  Wash Hub Monitor (/pickup-schedules-page): Live capacity telemetry for 6 washers &amp; 4 dryers.</a:t>
-            </a:r>
-          </a:p>
-          <a:p>
-            <a:pPr>
-              <a:spcBef>
-                <a:spcPts val="400"/>
-              </a:spcBef>
-              <a:spcAft>
-                <a:spcPts val="400"/>
-              </a:spcAft>
-              <a:defRPr sz="1200">
-                <a:solidFill>
-                  <a:srgbClr val="475569"/>
-                </a:solidFill>
-                <a:latin typeface="Calibri"/>
-              </a:defRPr>
-            </a:pPr>
-            <a:r>
-              <a:t>•  Slot Bottleneck Detector: Flags high intake density (&gt;4 bookings/slot).</a:t>
-            </a:r>
-          </a:p>
-        </p:txBody>
-      </p:sp>
-      <p:sp>
-        <p:nvSpPr>
-          <p:cNvPr id="6" name="Rounded Rectangle 5"/>
-          <p:cNvSpPr/>
-          <p:nvPr/>
-        </p:nvSpPr>
-        <p:spPr>
-          <a:xfrm>
-            <a:off x="7991856" y="1600200"/>
-            <a:ext cx="3447288" cy="4663440"/>
-          </a:xfrm>
-          <a:prstGeom prst="roundRect">
-            <a:avLst/>
-          </a:prstGeom>
-          <a:solidFill>
-            <a:srgbClr val="FFFFFF"/>
-          </a:solidFill>
-          <a:ln w="19050">
-            <a:solidFill>
-              <a:srgbClr val="E2E8F0"/>
-            </a:solidFill>
-          </a:ln>
-        </p:spPr>
-        <p:style>
-          <a:lnRef idx="1">
-            <a:schemeClr val="accent1"/>
-          </a:lnRef>
-          <a:fillRef idx="3">
-            <a:schemeClr val="accent1"/>
-          </a:fillRef>
-          <a:effectRef idx="2">
-            <a:schemeClr val="accent1"/>
-          </a:effectRef>
-          <a:fontRef idx="minor">
-            <a:schemeClr val="lt1"/>
-          </a:fontRef>
-        </p:style>
-        <p:txBody>
-          <a:bodyPr rtlCol="0" anchor="ctr" wrap="square" lIns="228600" tIns="182880" rIns="228600" bIns="182880"/>
-          <a:lstStyle/>
-          <a:p>
-            <a:pPr algn="ctr">
-              <a:spcAft>
-                <a:spcPts val="800"/>
-              </a:spcAft>
-              <a:defRPr sz="1500" b="1">
-                <a:solidFill>
-                  <a:srgbClr val="1E3A8A"/>
-                </a:solidFill>
-                <a:latin typeface="Arial"/>
-              </a:defRPr>
-            </a:pPr>
-            <a:r>
-              <a:t>🛵  Rider Mobile Web App</a:t>
-            </a:r>
-          </a:p>
-          <a:p>
-            <a:pPr>
-              <a:spcBef>
-                <a:spcPts val="400"/>
-              </a:spcBef>
-              <a:spcAft>
-                <a:spcPts val="400"/>
-              </a:spcAft>
-              <a:defRPr sz="1200">
-                <a:solidFill>
-                  <a:srgbClr val="475569"/>
-                </a:solidFill>
-                <a:latin typeface="Calibri"/>
-              </a:defRPr>
-            </a:pPr>
-            <a:r>
-              <a:t>•  Field Courier Interface (/rider-app): Optimized for motorcycle smartphone mounts.</a:t>
-            </a:r>
-          </a:p>
-          <a:p>
-            <a:pPr>
-              <a:spcBef>
-                <a:spcPts val="400"/>
-              </a:spcBef>
-              <a:spcAft>
-                <a:spcPts val="400"/>
-              </a:spcAft>
-              <a:defRPr sz="1200">
-                <a:solidFill>
-                  <a:srgbClr val="475569"/>
-                </a:solidFill>
-                <a:latin typeface="Calibri"/>
-              </a:defRPr>
-            </a:pPr>
-            <a:r>
-              <a:t>•  1-Tap GPS Navigation: Direct shortcuts into Google Maps &amp; Waze.</a:t>
-            </a:r>
-          </a:p>
-          <a:p>
-            <a:pPr>
-              <a:spcBef>
-                <a:spcPts val="400"/>
-              </a:spcBef>
-              <a:spcAft>
-                <a:spcPts val="400"/>
-              </a:spcAft>
-              <a:defRPr sz="1200">
-                <a:solidFill>
-                  <a:srgbClr val="475569"/>
-                </a:solidFill>
-                <a:latin typeface="Calibri"/>
-              </a:defRPr>
-            </a:pPr>
-            <a:r>
-              <a:t>•  Quick Client Calling: 1-tap phone dialer for arrival coordination.</a:t>
-            </a:r>
-          </a:p>
-          <a:p>
-            <a:pPr>
-              <a:spcBef>
-                <a:spcPts val="400"/>
-              </a:spcBef>
-              <a:spcAft>
-                <a:spcPts val="400"/>
-              </a:spcAft>
-              <a:defRPr sz="1200">
-                <a:solidFill>
-                  <a:srgbClr val="475569"/>
-                </a:solidFill>
-                <a:latin typeface="Calibri"/>
-              </a:defRPr>
-            </a:pPr>
-            <a:r>
-              <a:t>•  HTML5 Signature Canvas: Paperless touch signature handover.</a:t>
-            </a:r>
-          </a:p>
-        </p:txBody>
-      </p:sp>
-    </p:spTree>
-  </p:cSld>
-  <p:clrMapOvr>
-    <a:masterClrMapping/>
-  </p:clrMapOvr>
-</p:sld>
-</file>
-
-<file path=ppt/slides/slide5.xml><?xml version="1.0" encoding="utf-8"?>
-<p:sld xmlns:a="http://schemas.openxmlformats.org/drawingml/2006/main" xmlns:p="http://schemas.openxmlformats.org/presentationml/2006/main" xmlns:r="http://schemas.openxmlformats.org/officeDocument/2006/relationships">
-  <p:cSld>
-    <p:spTree>
-      <p:nvGrpSpPr>
-        <p:cNvPr id="1" name=""/>
-        <p:cNvGrpSpPr/>
-        <p:nvPr/>
-      </p:nvGrpSpPr>
-      <p:grpSpPr/>
-      <p:sp>
-        <p:nvSpPr>
-          <p:cNvPr id="2" name="Rectangle 1"/>
-          <p:cNvSpPr/>
-          <p:nvPr/>
-        </p:nvSpPr>
-        <p:spPr>
-          <a:xfrm>
-            <a:off x="0" y="0"/>
-            <a:ext cx="12191695" cy="6858000"/>
-          </a:xfrm>
-          <a:prstGeom prst="rect">
-            <a:avLst/>
-          </a:prstGeom>
-          <a:solidFill>
-            <a:srgbClr val="F8FAFC"/>
-          </a:solidFill>
-          <a:ln>
-            <a:noFill/>
-          </a:ln>
-        </p:spPr>
-        <p:style>
-          <a:lnRef idx="1">
-            <a:schemeClr val="accent1"/>
-          </a:lnRef>
-          <a:fillRef idx="3">
-            <a:schemeClr val="accent1"/>
-          </a:fillRef>
-          <a:effectRef idx="2">
-            <a:schemeClr val="accent1"/>
-          </a:effectRef>
-          <a:fontRef idx="minor">
-            <a:schemeClr val="lt1"/>
-          </a:fontRef>
-        </p:style>
-        <p:txBody>
-          <a:bodyPr rtlCol="0" anchor="ctr"/>
-          <a:lstStyle/>
-          <a:p>
-            <a:pPr algn="ctr"/>
-          </a:p>
-        </p:txBody>
-      </p:sp>
-      <p:sp>
-        <p:nvSpPr>
-          <p:cNvPr id="3" name="Rectangle 2"/>
-          <p:cNvSpPr/>
-          <p:nvPr/>
-        </p:nvSpPr>
-        <p:spPr>
-          <a:xfrm>
-            <a:off x="731520" y="365760"/>
-            <a:ext cx="10728655" cy="1005840"/>
-          </a:xfrm>
-          <a:prstGeom prst="rect">
-            <a:avLst/>
-          </a:prstGeom>
-          <a:solidFill>
-            <a:srgbClr val="FFFFFF"/>
-          </a:solidFill>
-          <a:ln w="12700">
-            <a:solidFill>
-              <a:srgbClr val="E2E8F0"/>
-            </a:solidFill>
-          </a:ln>
-        </p:spPr>
-        <p:style>
-          <a:lnRef idx="1">
-            <a:schemeClr val="accent1"/>
-          </a:lnRef>
-          <a:fillRef idx="3">
-            <a:schemeClr val="accent1"/>
-          </a:fillRef>
-          <a:effectRef idx="2">
-            <a:schemeClr val="accent1"/>
-          </a:effectRef>
-          <a:fontRef idx="minor">
-            <a:schemeClr val="lt1"/>
-          </a:fontRef>
-        </p:style>
-        <p:txBody>
-          <a:bodyPr rtlCol="0" anchor="ctr" wrap="square" lIns="228600" tIns="109728" rIns="228600" bIns="91440"/>
-          <a:lstStyle/>
-          <a:p>
-            <a:pPr algn="ctr">
-              <a:defRPr sz="1100" b="1">
-                <a:solidFill>
-                  <a:srgbClr val="2563EB"/>
-                </a:solidFill>
-                <a:latin typeface="Calibri"/>
-              </a:defRPr>
-            </a:pPr>
-            <a:r>
-              <a:t>PHASE 3: SOFTWARE ENGINEERING &amp; QA   •   PRESENTER: TRISTAN DAVE M. PLAZA (MOBILE UX LEAD &amp; COURIER 1)</a:t>
-            </a:r>
-          </a:p>
-          <a:p>
-            <a:pPr>
-              <a:spcBef>
-                <a:spcPts val="300"/>
-              </a:spcBef>
-              <a:defRPr sz="2000" b="1">
-                <a:solidFill>
-                  <a:srgbClr val="0F172A"/>
-                </a:solidFill>
-                <a:latin typeface="Arial"/>
-              </a:defRPr>
-            </a:pPr>
-            <a:r>
-              <a:t>Engineering Integrity: Architecture &amp; Adversarial Hardening</a:t>
-            </a:r>
-          </a:p>
-        </p:txBody>
-      </p:sp>
-      <p:sp>
-        <p:nvSpPr>
-          <p:cNvPr id="4" name="Rounded Rectangle 3"/>
-          <p:cNvSpPr/>
-          <p:nvPr/>
-        </p:nvSpPr>
-        <p:spPr>
-          <a:xfrm>
-            <a:off x="731520" y="1600200"/>
-            <a:ext cx="5266944" cy="4663440"/>
-          </a:xfrm>
-          <a:prstGeom prst="roundRect">
-            <a:avLst/>
-          </a:prstGeom>
-          <a:solidFill>
-            <a:srgbClr val="FFFFFF"/>
-          </a:solidFill>
-          <a:ln w="19050">
-            <a:solidFill>
-              <a:srgbClr val="E2E8F0"/>
-            </a:solidFill>
-          </a:ln>
-        </p:spPr>
-        <p:style>
-          <a:lnRef idx="1">
-            <a:schemeClr val="accent1"/>
-          </a:lnRef>
-          <a:fillRef idx="3">
-            <a:schemeClr val="accent1"/>
-          </a:fillRef>
-          <a:effectRef idx="2">
-            <a:schemeClr val="accent1"/>
-          </a:effectRef>
-          <a:fontRef idx="minor">
-            <a:schemeClr val="lt1"/>
-          </a:fontRef>
-        </p:style>
-        <p:txBody>
-          <a:bodyPr rtlCol="0" anchor="ctr" wrap="square" lIns="228600" tIns="182880" rIns="228600" bIns="182880"/>
-          <a:lstStyle/>
-          <a:p>
-            <a:pPr algn="ctr">
-              <a:spcAft>
-                <a:spcPts val="800"/>
-              </a:spcAft>
-              <a:defRPr sz="1500" b="1">
-                <a:solidFill>
-                  <a:srgbClr val="1E3A8A"/>
-                </a:solidFill>
-                <a:latin typeface="Arial"/>
-              </a:defRPr>
-            </a:pPr>
-            <a:r>
-              <a:t>🏗️  Modular System Architecture</a:t>
-            </a:r>
-          </a:p>
-          <a:p>
-            <a:pPr>
-              <a:spcBef>
-                <a:spcPts val="400"/>
-              </a:spcBef>
-              <a:spcAft>
-                <a:spcPts val="400"/>
-              </a:spcAft>
-              <a:defRPr sz="1200">
-                <a:solidFill>
-                  <a:srgbClr val="475569"/>
-                </a:solidFill>
-                <a:latin typeface="Calibri"/>
-              </a:defRPr>
-            </a:pPr>
-            <a:r>
-              <a:t>•  Backend Framework: Python 3 + Flask using 6 decoupled domain Blueprints (Customer, Order, Pickup, Delivery, Payment, Portal).</a:t>
-            </a:r>
-          </a:p>
-          <a:p>
-            <a:pPr>
-              <a:spcBef>
-                <a:spcPts val="400"/>
-              </a:spcBef>
-              <a:spcAft>
-                <a:spcPts val="400"/>
-              </a:spcAft>
-              <a:defRPr sz="1200">
-                <a:solidFill>
-                  <a:srgbClr val="475569"/>
-                </a:solidFill>
-                <a:latin typeface="Calibri"/>
-              </a:defRPr>
-            </a:pPr>
-            <a:r>
-              <a:t>•  Merge Conflict Prevention: Team members worked on separate controllers concurrently without Git collisions.</a:t>
-            </a:r>
-          </a:p>
-          <a:p>
-            <a:pPr>
-              <a:spcBef>
-                <a:spcPts val="400"/>
-              </a:spcBef>
-              <a:spcAft>
-                <a:spcPts val="400"/>
-              </a:spcAft>
-              <a:defRPr sz="1200">
-                <a:solidFill>
-                  <a:srgbClr val="475569"/>
-                </a:solidFill>
-                <a:latin typeface="Calibri"/>
-              </a:defRPr>
-            </a:pPr>
-            <a:r>
-              <a:t>•  Database Architecture: SQLite 3 with enforced foreign keys (PRAGMA foreign_keys = ON) and automatic cold-start migrations.</a:t>
-            </a:r>
-          </a:p>
-          <a:p>
-            <a:pPr>
-              <a:spcBef>
-                <a:spcPts val="400"/>
-              </a:spcBef>
-              <a:spcAft>
-                <a:spcPts val="400"/>
-              </a:spcAft>
-              <a:defRPr sz="1200">
-                <a:solidFill>
-                  <a:srgbClr val="475569"/>
-                </a:solidFill>
-                <a:latin typeface="Calibri"/>
-              </a:defRPr>
-            </a:pPr>
-            <a:r>
-              <a:t>•  Dual-Mode Error Handler: Returns JSON for AJAX fetch calls and branded HTML for browser navigation (zero stack trace leakage).</a:t>
-            </a:r>
-          </a:p>
-          <a:p>
-            <a:pPr>
-              <a:spcBef>
-                <a:spcPts val="400"/>
-              </a:spcBef>
-              <a:spcAft>
-                <a:spcPts val="400"/>
-              </a:spcAft>
-              <a:defRPr sz="1200">
-                <a:solidFill>
-                  <a:srgbClr val="475569"/>
-                </a:solidFill>
-                <a:latin typeface="Calibri"/>
-              </a:defRPr>
-            </a:pPr>
-            <a:r>
-              <a:t>•  Role-Based Access Control: Decorator checks session roles (Admin, Staff, Rider) preventing privilege escalation.</a:t>
-            </a:r>
-          </a:p>
-        </p:txBody>
-      </p:sp>
-      <p:sp>
-        <p:nvSpPr>
-          <p:cNvPr id="5" name="Rounded Rectangle 4"/>
-          <p:cNvSpPr/>
-          <p:nvPr/>
-        </p:nvSpPr>
-        <p:spPr>
-          <a:xfrm>
-            <a:off x="6181344" y="1600200"/>
-            <a:ext cx="5276088" cy="4663440"/>
-          </a:xfrm>
-          <a:prstGeom prst="roundRect">
-            <a:avLst/>
-          </a:prstGeom>
-          <a:solidFill>
-            <a:srgbClr val="FFFFFF"/>
-          </a:solidFill>
-          <a:ln w="19050">
-            <a:solidFill>
-              <a:srgbClr val="E2E8F0"/>
-            </a:solidFill>
-          </a:ln>
-        </p:spPr>
-        <p:style>
-          <a:lnRef idx="1">
-            <a:schemeClr val="accent1"/>
-          </a:lnRef>
-          <a:fillRef idx="3">
-            <a:schemeClr val="accent1"/>
-          </a:fillRef>
-          <a:effectRef idx="2">
-            <a:schemeClr val="accent1"/>
-          </a:effectRef>
-          <a:fontRef idx="minor">
-            <a:schemeClr val="lt1"/>
-          </a:fontRef>
-        </p:style>
-        <p:txBody>
-          <a:bodyPr rtlCol="0" anchor="ctr" wrap="square" lIns="228600" tIns="182880" rIns="228600" bIns="182880"/>
-          <a:lstStyle/>
-          <a:p>
-            <a:pPr algn="ctr">
-              <a:spcAft>
-                <a:spcPts val="800"/>
-              </a:spcAft>
-              <a:defRPr sz="1500" b="1">
-                <a:solidFill>
-                  <a:srgbClr val="1E3A8A"/>
-                </a:solidFill>
-                <a:latin typeface="Arial"/>
-              </a:defRPr>
-            </a:pPr>
-            <a:r>
-              <a:t>🛡️  Adversarial Security &amp; Test Evidence</a:t>
-            </a:r>
-          </a:p>
-          <a:p>
-            <a:pPr>
-              <a:spcBef>
-                <a:spcPts val="400"/>
-              </a:spcBef>
-              <a:spcAft>
-                <a:spcPts val="400"/>
-              </a:spcAft>
-              <a:defRPr sz="1200">
-                <a:solidFill>
-                  <a:srgbClr val="475569"/>
-                </a:solidFill>
-                <a:latin typeface="Calibri"/>
-              </a:defRPr>
-            </a:pPr>
-            <a:r>
-              <a:t>•  Stored XSS Sanitization (BUG-001): Regex-based tag stripper (strip_html_tags()) purges &lt;script&gt; and &lt;style&gt; tags before database storage.</a:t>
-            </a:r>
-          </a:p>
-          <a:p>
-            <a:pPr>
-              <a:spcBef>
-                <a:spcPts val="400"/>
-              </a:spcBef>
-              <a:spcAft>
-                <a:spcPts val="400"/>
-              </a:spcAft>
-              <a:defRPr sz="1200">
-                <a:solidFill>
-                  <a:srgbClr val="475569"/>
-                </a:solidFill>
-                <a:latin typeface="Calibri"/>
-              </a:defRPr>
-            </a:pPr>
-            <a:r>
-              <a:t>•  Physical Capacity Ceiling (BUG-002): Caps single order weight at 150.0 kg. Oversized loads return HTTP 422 commercial warning.</a:t>
-            </a:r>
-          </a:p>
-          <a:p>
-            <a:pPr>
-              <a:spcBef>
-                <a:spcPts val="400"/>
-              </a:spcBef>
-              <a:spcAft>
-                <a:spcPts val="400"/>
-              </a:spcAft>
-              <a:defRPr sz="1200">
-                <a:solidFill>
-                  <a:srgbClr val="475569"/>
-                </a:solidFill>
-                <a:latin typeface="Calibri"/>
-              </a:defRPr>
-            </a:pPr>
-            <a:r>
-              <a:t>•  Historical Date Prevention (BUG-003): Dynamic min date attribute and server-side checks block bookings in the past.</a:t>
-            </a:r>
-          </a:p>
-          <a:p>
-            <a:pPr>
-              <a:spcBef>
-                <a:spcPts val="400"/>
-              </a:spcBef>
-              <a:spcAft>
-                <a:spcPts val="400"/>
-              </a:spcAft>
-              <a:defRPr sz="1200">
-                <a:solidFill>
-                  <a:srgbClr val="475569"/>
-                </a:solidFill>
-                <a:latin typeface="Calibri"/>
-              </a:defRPr>
-            </a:pPr>
-            <a:r>
-              <a:t>•  Modal Freezing Resolution (BUG-004): Universal Escape key event handler cleanly dismisses dialogs across all browsers.</a:t>
-            </a:r>
-          </a:p>
-          <a:p>
-            <a:pPr>
-              <a:spcBef>
-                <a:spcPts val="400"/>
-              </a:spcBef>
-              <a:spcAft>
-                <a:spcPts val="400"/>
-              </a:spcAft>
-              <a:defRPr sz="1200">
-                <a:solidFill>
-                  <a:srgbClr val="475569"/>
-                </a:solidFill>
-                <a:latin typeface="Calibri"/>
-              </a:defRPr>
-            </a:pPr>
-            <a:r>
-              <a:t>•  78 / 78 Passing Pytest Tests: 100% green suite validating RBAC, arithmetic precision, and adversarial boundary limits.</a:t>
-            </a:r>
-          </a:p>
-        </p:txBody>
-      </p:sp>
-    </p:spTree>
-  </p:cSld>
-  <p:clrMapOvr>
-    <a:masterClrMapping/>
-  </p:clrMapOvr>
-</p:sld>
-</file>
-
-<file path=ppt/slides/slide6.xml><?xml version="1.0" encoding="utf-8"?>
-<p:sld xmlns:a="http://schemas.openxmlformats.org/drawingml/2006/main" xmlns:p="http://schemas.openxmlformats.org/presentationml/2006/main" xmlns:r="http://schemas.openxmlformats.org/officeDocument/2006/relationships">
-  <p:cSld>
-    <p:spTree>
-      <p:nvGrpSpPr>
-        <p:cNvPr id="1" name=""/>
-        <p:cNvGrpSpPr/>
-        <p:nvPr/>
-      </p:nvGrpSpPr>
-      <p:grpSpPr/>
-      <p:sp>
-        <p:nvSpPr>
-          <p:cNvPr id="2" name="Rectangle 1"/>
-          <p:cNvSpPr/>
-          <p:nvPr/>
-        </p:nvSpPr>
-        <p:spPr>
-          <a:xfrm>
-            <a:off x="0" y="0"/>
-            <a:ext cx="12191695" cy="6858000"/>
-          </a:xfrm>
-          <a:prstGeom prst="rect">
-            <a:avLst/>
-          </a:prstGeom>
-          <a:solidFill>
-            <a:srgbClr val="F8FAFC"/>
-          </a:solidFill>
-          <a:ln>
-            <a:noFill/>
-          </a:ln>
-        </p:spPr>
-        <p:style>
-          <a:lnRef idx="1">
-            <a:schemeClr val="accent1"/>
-          </a:lnRef>
-          <a:fillRef idx="3">
-            <a:schemeClr val="accent1"/>
-          </a:fillRef>
-          <a:effectRef idx="2">
-            <a:schemeClr val="accent1"/>
-          </a:effectRef>
-          <a:fontRef idx="minor">
-            <a:schemeClr val="lt1"/>
-          </a:fontRef>
-        </p:style>
-        <p:txBody>
-          <a:bodyPr rtlCol="0" anchor="ctr"/>
-          <a:lstStyle/>
-          <a:p>
-            <a:pPr algn="ctr"/>
-          </a:p>
-        </p:txBody>
-      </p:sp>
-      <p:sp>
-        <p:nvSpPr>
-          <p:cNvPr id="3" name="Rectangle 2"/>
-          <p:cNvSpPr/>
-          <p:nvPr/>
-        </p:nvSpPr>
-        <p:spPr>
-          <a:xfrm>
-            <a:off x="731520" y="365760"/>
-            <a:ext cx="10728655" cy="1005840"/>
-          </a:xfrm>
-          <a:prstGeom prst="rect">
-            <a:avLst/>
-          </a:prstGeom>
-          <a:solidFill>
-            <a:srgbClr val="FFFFFF"/>
-          </a:solidFill>
-          <a:ln w="12700">
-            <a:solidFill>
-              <a:srgbClr val="E2E8F0"/>
-            </a:solidFill>
-          </a:ln>
-        </p:spPr>
-        <p:style>
-          <a:lnRef idx="1">
-            <a:schemeClr val="accent1"/>
-          </a:lnRef>
-          <a:fillRef idx="3">
-            <a:schemeClr val="accent1"/>
-          </a:fillRef>
-          <a:effectRef idx="2">
-            <a:schemeClr val="accent1"/>
-          </a:effectRef>
-          <a:fontRef idx="minor">
-            <a:schemeClr val="lt1"/>
-          </a:fontRef>
-        </p:style>
-        <p:txBody>
-          <a:bodyPr rtlCol="0" anchor="ctr" wrap="square" lIns="228600" tIns="109728" rIns="228600" bIns="91440"/>
-          <a:lstStyle/>
-          <a:p>
-            <a:pPr algn="ctr">
-              <a:defRPr sz="1100" b="1">
-                <a:solidFill>
-                  <a:srgbClr val="2563EB"/>
-                </a:solidFill>
-                <a:latin typeface="Calibri"/>
-              </a:defRPr>
-            </a:pPr>
-            <a:r>
-              <a:t>PHASE 4: OPERATIONS &amp; DEMONSTRATION   •   PRESENTER: MARVIN OCLARINO (FINANCIAL SETTLEMENT LEAD &amp; COURIER 2)</a:t>
-            </a:r>
-          </a:p>
-          <a:p>
-            <a:pPr>
-              <a:spcBef>
-                <a:spcPts val="300"/>
-              </a:spcBef>
-              <a:defRPr sz="2000" b="1">
-                <a:solidFill>
-                  <a:srgbClr val="0F172A"/>
-                </a:solidFill>
-                <a:latin typeface="Arial"/>
-              </a:defRPr>
-            </a:pPr>
-            <a:r>
-              <a:t>Motorcycle Logistics, Financial Settlement &amp; Live Demo</a:t>
+              <a:t>Motorcycle Logistics, POS Settlement &amp; Live System Demo</a:t>
             </a:r>
           </a:p>
         </p:txBody>
@@ -5766,7 +5346,7 @@
               </a:defRPr>
             </a:pPr>
             <a:r>
-              <a:t>🗺️  Base Camp Motorcycle Logistics</a:t>
+              <a:t>🗺️  Base Camp Bajaj Motorcycle Logistics</a:t>
             </a:r>
           </a:p>
           <a:p>
@@ -5804,7 +5384,7 @@
               </a:defRPr>
             </a:pPr>
             <a:r>
-              <a:t>•  Zone 1 (Proper &amp; Commercial Junction): Dispatched to Tristan Dave Plaza (Motorcycle 1).</a:t>
+              <a:t>•  Zone 1 (Proper &amp; Commercial Junction): Dispatched to Tristan Dave Plaza (Bajaj Moto 1).</a:t>
             </a:r>
           </a:p>
           <a:p>
@@ -5823,7 +5403,7 @@
               </a:defRPr>
             </a:pPr>
             <a:r>
-              <a:t>•  Zone 2 (Sayre Highway Corridor &amp; Strip): Dispatched to Marvin Oclarino (Motorcycle 2).</a:t>
+              <a:t>•  Zone 2 (Sayre Highway Corridor &amp; Strip): Dispatched to Marvin Oclarino (Bajaj Moto 2).</a:t>
             </a:r>
           </a:p>
           <a:p>
@@ -5842,7 +5422,7 @@
               </a:defRPr>
             </a:pPr>
             <a:r>
-              <a:t>•  Zone 3 (Puroks 1 to 5 Residential): Dispatched to Mark Ephraim Nicor (Motorcycle 3).</a:t>
+              <a:t>•  Zone 3 (Puroks 1 to 5 Residential): Dispatched to Mark Ephraim Nicor (Bajaj Moto 3).</a:t>
             </a:r>
           </a:p>
           <a:p>
@@ -5919,7 +5499,7 @@
               </a:defRPr>
             </a:pPr>
             <a:r>
-              <a:t>💳  Doorstep Financial POS Settlement</a:t>
+              <a:t>💳  Doorstep Financial POS &amp; Contact Hub</a:t>
             </a:r>
           </a:p>
           <a:p>
@@ -5976,7 +5556,7 @@
               </a:defRPr>
             </a:pPr>
             <a:r>
-              <a:t>•  Multi-Channel Breakdown: Tracks Cash, GCash, and Bank Transfer with zero-division safety protection.</a:t>
+              <a:t>•  Customer Hotline &amp; Socials: Official Hotline 0906-188-8611 • Store Hours: 8:00 AM - 4:30 PM (Mon-Sat).</a:t>
             </a:r>
           </a:p>
           <a:p>
@@ -5995,7 +5575,7 @@
               </a:defRPr>
             </a:pPr>
             <a:r>
-              <a:t>•  Verifiable Proof of Delivery: Base64 touch signature stored directly with the delivery record.</a:t>
+              <a:t>•  Official Facebook Page: Direct integration to https://www.facebook.com/LaundryCare.</a:t>
             </a:r>
           </a:p>
         </p:txBody>
@@ -6050,7 +5630,7 @@
               </a:defRPr>
             </a:pPr>
             <a:r>
-              <a:t>READY FOR LIVE DEMONSTRATION  •  TRANSITIONING TO BROWSER</a:t>
+              <a:t>LIVE SYSTEM DEMONSTRATION WORKFLOW  •  TRANSITIONING TO APPLICATION</a:t>
             </a:r>
           </a:p>
           <a:p>
@@ -6066,7 +5646,7 @@
               </a:defRPr>
             </a:pPr>
             <a:r>
-              <a:t>Live Demo Steps: 1. Public Booking  ➔  2. Scale Weighing &amp; Pricing  ➔  3. Wash Hub Telemetry  ➔  4. Customer Tracker  ➔  5. Mobile Touch Signature Handover  ➔  6. Thermal POS Receipt &amp; Change Helper.</a:t>
+              <a:t>Demo Steps: 1. Public 60s Booking (/book-pickup)  ➔  2. Scale Weighing &amp; Pricing (/laundry-orders-page)  ➔  3. Wash Hub Telemetry (/pickup-schedules-page)  ➔  4. Customer Tracker (/track)  ➔  5. Mobile Courier Touch Signature (/rider-app)  ➔  6. Thermal POS Receipt &amp; Payment Settlement (/payments-page).</a:t>
             </a:r>
           </a:p>
         </p:txBody>

</xml_diff>

<commit_message>
docs(presentation): simplify slide wording for natural human presentation flow
</commit_message>
<xml_diff>
--- a/LaundryCare_Presentation.pptx
+++ b/LaundryCare_Presentation.pptx
@@ -3177,13 +3177,13 @@
             <a:pPr algn="ctr">
               <a:defRPr sz="1100" b="1">
                 <a:solidFill>
-                  <a:srgbClr val="93C5FD"/>
-                </a:solidFill>
-                <a:latin typeface="Calibri"/>
-              </a:defRPr>
-            </a:pPr>
-            <a:r>
-              <a:t>CS 106 / SOFTWARE ENGINEERING 1  •  FINAL SYSTEM DEFENSE &amp; LIVE DEMO</a:t>
+                  <a:srgbClr val="93C8FD"/>
+                </a:solidFill>
+                <a:latin typeface="Calibri"/>
+              </a:defRPr>
+            </a:pPr>
+            <a:r>
+              <a:t>FINAL PROJECT DEFENSE &amp; SYSTEM DEMO</a:t>
             </a:r>
           </a:p>
           <a:p>
@@ -3215,7 +3215,7 @@
               </a:defRPr>
             </a:pPr>
             <a:r>
-              <a:t>Automated Doorstep Laundry ERP &amp; Sector-Based Logistics for Barangay Base Camp, Maramag, Bukidnon</a:t>
+              <a:t>Doorstep Laundry Pickup and Delivery System for Base Camp, Maramag, Bukidnon</a:t>
             </a:r>
           </a:p>
         </p:txBody>
@@ -3273,7 +3273,7 @@
               </a:defRPr>
             </a:pPr>
             <a:r>
-              <a:t>PROJECT TEAM &amp; CODEBASE OWNERSHIP</a:t>
+              <a:t>OUR TEAM &amp; ROLES</a:t>
             </a:r>
           </a:p>
           <a:p>
@@ -3286,7 +3286,7 @@
               </a:defRPr>
             </a:pPr>
             <a:r>
-              <a:t>•  John Michael Bretaña — Lead Architect &amp; Branch Manager</a:t>
+              <a:t>•  John Michael Bretaña — Project Leader &amp; Admin</a:t>
             </a:r>
           </a:p>
           <a:p>
@@ -3302,7 +3302,7 @@
               </a:defRPr>
             </a:pPr>
             <a:r>
-              <a:t>    Domain: Core Architecture, RBAC, Cloud Deployment</a:t>
+              <a:t>    Role: Overall system design, user permissions, and deployment</a:t>
             </a:r>
           </a:p>
           <a:p>
@@ -3315,7 +3315,7 @@
               </a:defRPr>
             </a:pPr>
             <a:r>
-              <a:t>•  Hazil Enoc — Store Cashier &amp; CRM Lead</a:t>
+              <a:t>•  Hazil Enoc — Front Desk Cashier</a:t>
             </a:r>
           </a:p>
           <a:p>
@@ -3331,7 +3331,7 @@
               </a:defRPr>
             </a:pPr>
             <a:r>
-              <a:t>    Domain: Customer Loyalty Engine, Digital Weighing &amp; POS</a:t>
+              <a:t>    Role: Customer records, order encoding, and billing</a:t>
             </a:r>
           </a:p>
           <a:p>
@@ -3344,7 +3344,7 @@
               </a:defRPr>
             </a:pPr>
             <a:r>
-              <a:t>•  Mark Ephraim Nicor — Laundry Operator &amp; Courier 3</a:t>
+              <a:t>•  Mark Ephraim Nicor — Laundry Operator &amp; Rider 3</a:t>
             </a:r>
           </a:p>
           <a:p>
@@ -3360,7 +3360,7 @@
               </a:defRPr>
             </a:pPr>
             <a:r>
-              <a:t>    Domain: Wash Hub Telemetry, Machine Densities &amp; Zone 3</a:t>
+              <a:t>    Role: Washing and drying schedule, deliveries for Puroks 1-5</a:t>
             </a:r>
           </a:p>
           <a:p>
@@ -3373,7 +3373,7 @@
               </a:defRPr>
             </a:pPr>
             <a:r>
-              <a:t>•  Tristan Dave M. Plaza — Mobile UX Lead &amp; Courier 1</a:t>
+              <a:t>•  Tristan Dave M. Plaza — Mobile App &amp; Rider 1</a:t>
             </a:r>
           </a:p>
           <a:p>
@@ -3389,7 +3389,7 @@
               </a:defRPr>
             </a:pPr>
             <a:r>
-              <a:t>    Domain: Rider Mobile Web App, Touch Signature &amp; Zone 1</a:t>
+              <a:t>    Role: Rider mobile view, digital signature, deliveries for Base Camp Proper</a:t>
             </a:r>
           </a:p>
           <a:p>
@@ -3402,7 +3402,7 @@
               </a:defRPr>
             </a:pPr>
             <a:r>
-              <a:t>•  Marvin Oclarino — Financial Lead &amp; Courier 2</a:t>
+              <a:t>•  Marvin Oclarino — Payments &amp; Rider 2</a:t>
             </a:r>
           </a:p>
           <a:p>
@@ -3418,7 +3418,7 @@
               </a:defRPr>
             </a:pPr>
             <a:r>
-              <a:t>    Domain: Doorstep Change Calculator, Thermal POS &amp; Zone 2</a:t>
+              <a:t>    Role: Payment recording, change calculator, deliveries along Highway</a:t>
             </a:r>
           </a:p>
         </p:txBody>
@@ -3476,20 +3476,20 @@
               </a:defRPr>
             </a:pPr>
             <a:r>
-              <a:t>KEY PROJECT HIGHLIGHTS</a:t>
+              <a:t>QUICK PROJECT OVERVIEW</a:t>
             </a:r>
           </a:p>
           <a:p>
             <a:pPr>
               <a:defRPr sz="1200" b="1">
                 <a:solidFill>
-                  <a:srgbClr val="059669"/>
-                </a:solidFill>
-                <a:latin typeface="Calibri"/>
-              </a:defRPr>
-            </a:pPr>
-            <a:r>
-              <a:t>✅ 79 / 79 Passing Tests</a:t>
+                  <a:srgbClr val="2563EB"/>
+                </a:solidFill>
+                <a:latin typeface="Calibri"/>
+              </a:defRPr>
+            </a:pPr>
+            <a:r>
+              <a:t>📍 Location Covered</a:t>
             </a:r>
           </a:p>
           <a:p>
@@ -3505,7 +3505,7 @@
               </a:defRPr>
             </a:pPr>
             <a:r>
-              <a:t>100% green automated Pytest test suite covering RBAC, arithmetic, and failure paths.</a:t>
+              <a:t>Exclusively serves Barangay Base Camp, Maramag, Bukidnon.</a:t>
             </a:r>
           </a:p>
           <a:p>
@@ -3518,7 +3518,7 @@
               </a:defRPr>
             </a:pPr>
             <a:r>
-              <a:t>🌐 Live Cloud Deployment</a:t>
+              <a:t>🛵 3 Bajaj Delivery Motorcycles</a:t>
             </a:r>
           </a:p>
           <a:p>
@@ -3534,7 +3534,7 @@
               </a:defRPr>
             </a:pPr>
             <a:r>
-              <a:t>Hosted on Render PaaS (Linux Gunicorn WSGI) with offline local hot standby.</a:t>
+              <a:t>3 dedicated riders assigned to specific neighborhood zones.</a:t>
             </a:r>
           </a:p>
           <a:p>
@@ -3547,7 +3547,7 @@
               </a:defRPr>
             </a:pPr>
             <a:r>
-              <a:t>🛵 100% Bajaj Motorcycle Fleet</a:t>
+              <a:t>📞 Contact &amp; Support</a:t>
             </a:r>
           </a:p>
           <a:p>
@@ -3563,7 +3563,7 @@
               </a:defRPr>
             </a:pPr>
             <a:r>
-              <a:t>Exclusively customized for Barangay Base Camp sectors with 3 dedicated riders.</a:t>
+              <a:t>Hotline: 0906-188-8611 • Hours: 8:00 AM - 4:30 PM (Mon-Sat).</a:t>
             </a:r>
           </a:p>
           <a:p>
@@ -3576,7 +3576,7 @@
               </a:defRPr>
             </a:pPr>
             <a:r>
-              <a:t>✍️ Paperless Touch Signatures</a:t>
+              <a:t>✅ Fully Tested &amp; Working</a:t>
             </a:r>
           </a:p>
           <a:p>
@@ -3592,7 +3592,7 @@
               </a:defRPr>
             </a:pPr>
             <a:r>
-              <a:t>HTML5 Canvas touch signatures for verifiable proof of delivery.</a:t>
+              <a:t>Passed all 79 automated software tests with 0 errors.</a:t>
             </a:r>
           </a:p>
         </p:txBody>
@@ -3696,7 +3696,7 @@
           </a:fontRef>
         </p:style>
         <p:txBody>
-          <a:bodyPr rtlCol="0" anchor="ctr" wrap="square" lIns="228600" tIns="109728" rIns="228600" bIns="91440"/>
+          <a:bodyPr rtlCol="0" anchor="ctr" wrap="square" lIns="274320" tIns="109728" rIns="228600" bIns="91440"/>
           <a:lstStyle/>
           <a:p>
             <a:pPr algn="ctr">
@@ -3708,7 +3708,7 @@
               </a:defRPr>
             </a:pPr>
             <a:r>
-              <a:t>PHASE 1: PROBLEM DEFINITION   •   PRESENTER: HAZIL ENOC (STORE CASHIER &amp; CRM LEAD)</a:t>
+              <a:t>WHY WE BUILT THIS   •   PRESENTER: HAZIL ENOC (FRONT DESK CASHIER)</a:t>
             </a:r>
           </a:p>
           <a:p>
@@ -3724,7 +3724,7 @@
               </a:defRPr>
             </a:pPr>
             <a:r>
-              <a:t>The Challenge: Operational Gaps in Traditional Laundry Shops</a:t>
+              <a:t>The Problem: What Traditional Laundry Shops Struggle With</a:t>
             </a:r>
           </a:p>
         </p:txBody>
@@ -3782,7 +3782,7 @@
               </a:defRPr>
             </a:pPr>
             <a:r>
-              <a:t>🏷️  Lost Paper Slips &amp; Tags</a:t>
+              <a:t>🏷️  Lost Paper Slips</a:t>
             </a:r>
           </a:p>
           <a:p>
@@ -3801,7 +3801,7 @@
               </a:defRPr>
             </a:pPr>
             <a:r>
-              <a:t>•  Physical paper receipts get torn, wet, or lost on the shop floor.</a:t>
+              <a:t>•  Paper receipts get wet, torn, or misplaced on the counter.</a:t>
             </a:r>
           </a:p>
           <a:p>
@@ -3820,7 +3820,7 @@
               </a:defRPr>
             </a:pPr>
             <a:r>
-              <a:t>•  Manual identification tags lead to misplaced garments and bag mix-ups.</a:t>
+              <a:t>•  Handwritten tags fall off bags, causing mixed-up clothes.</a:t>
             </a:r>
           </a:p>
           <a:p>
@@ -3839,7 +3839,7 @@
               </a:defRPr>
             </a:pPr>
             <a:r>
-              <a:t>•  Zero permanent digital audit trail for customer service histories.</a:t>
+              <a:t>•  Hard to look up past customer records when using paper notebooks.</a:t>
             </a:r>
           </a:p>
         </p:txBody>
@@ -3897,7 +3897,7 @@
               </a:defRPr>
             </a:pPr>
             <a:r>
-              <a:t>👀  Customer Blindspots</a:t>
+              <a:t>👀  No Status Tracking</a:t>
             </a:r>
           </a:p>
           <a:p>
@@ -3916,7 +3916,7 @@
               </a:defRPr>
             </a:pPr>
             <a:r>
-              <a:t>•  Clients have zero visibility into washing and drying stages.</a:t>
+              <a:t>•  Customers don't know if their clothes are currently being washed or dried.</a:t>
             </a:r>
           </a:p>
           <a:p>
@@ -3935,7 +3935,7 @@
               </a:defRPr>
             </a:pPr>
             <a:r>
-              <a:t>•  Students and busy families repeatedly call staff asking if laundry is ready.</a:t>
+              <a:t>•  Students and busy families keep calling to ask if their laundry is ready.</a:t>
             </a:r>
           </a:p>
           <a:p>
@@ -3954,7 +3954,7 @@
               </a:defRPr>
             </a:pPr>
             <a:r>
-              <a:t>•  No digital notifications when riders are en route for collection.</a:t>
+              <a:t>•  No notifications sent when riders are already on the way.</a:t>
             </a:r>
           </a:p>
         </p:txBody>
@@ -4012,7 +4012,7 @@
               </a:defRPr>
             </a:pPr>
             <a:r>
-              <a:t>🛵  Uncoordinated Couriers</a:t>
+              <a:t>🛵  Messy Delivery Dispatch</a:t>
             </a:r>
           </a:p>
           <a:p>
@@ -4031,7 +4031,7 @@
               </a:defRPr>
             </a:pPr>
             <a:r>
-              <a:t>•  Riders receive unstructured phone calls with unclear landmarks.</a:t>
+              <a:t>•  Riders only get text messages without clear addresses or landmarks.</a:t>
             </a:r>
           </a:p>
           <a:p>
@@ -4050,7 +4050,7 @@
               </a:defRPr>
             </a:pPr>
             <a:r>
-              <a:t>•  No sector planning leads to overlapping routes and wasted fuel.</a:t>
+              <a:t>•  Riders overlap in the same area, wasting time and motorcycle fuel.</a:t>
             </a:r>
           </a:p>
           <a:p>
@@ -4069,7 +4069,7 @@
               </a:defRPr>
             </a:pPr>
             <a:r>
-              <a:t>•  Peak intake hours overwhelm couriers without scheduling density checks.</a:t>
+              <a:t>•  Too many pickup requests during peak hours can overwhelm riders.</a:t>
             </a:r>
           </a:p>
         </p:txBody>
@@ -4127,7 +4127,7 @@
               </a:defRPr>
             </a:pPr>
             <a:r>
-              <a:t>🧮  Doorstep Math Errors</a:t>
+              <a:t>🧮  Manual Math &amp; Change Errors</a:t>
             </a:r>
           </a:p>
           <a:p>
@@ -4146,7 +4146,7 @@
               </a:defRPr>
             </a:pPr>
             <a:r>
-              <a:t>•  Couriers mentally compute per-kilogram rates and cash change on the road.</a:t>
+              <a:t>•  Riders calculate rates and change in their head at the doorstep.</a:t>
             </a:r>
           </a:p>
           <a:p>
@@ -4165,7 +4165,7 @@
               </a:defRPr>
             </a:pPr>
             <a:r>
-              <a:t>•  Cashier end-of-day reconciliation deficits from arithmetic mistakes.</a:t>
+              <a:t>•  Mental math mistakes cause short cash at the end of the day.</a:t>
             </a:r>
           </a:p>
           <a:p>
@@ -4184,7 +4184,7 @@
               </a:defRPr>
             </a:pPr>
             <a:r>
-              <a:t>•  Lack of digital Proof of Delivery (POD) signatures causes disputes.</a:t>
+              <a:t>•  No digital signature or proof that the laundry was actually received.</a:t>
             </a:r>
           </a:p>
         </p:txBody>
@@ -4288,7 +4288,7 @@
           </a:fontRef>
         </p:style>
         <p:txBody>
-          <a:bodyPr rtlCol="0" anchor="ctr" wrap="square" lIns="228600" tIns="109728" rIns="228600" bIns="91440"/>
+          <a:bodyPr rtlCol="0" anchor="ctr" wrap="square" lIns="274320" tIns="109728" rIns="228600" bIns="91440"/>
           <a:lstStyle/>
           <a:p>
             <a:pPr algn="ctr">
@@ -4300,7 +4300,7 @@
               </a:defRPr>
             </a:pPr>
             <a:r>
-              <a:t>PHASE 2: SOLUTION ARCHITECTURE   •   PRESENTER: MARK EPHRAIM NICOR (LAUNDRY OPERATOR &amp; COURIER 3)</a:t>
+              <a:t>OUR SOLUTION   •   PRESENTER: MARK EPHRAIM NICOR (LAUNDRY OPERATOR &amp; RIDER 3)</a:t>
             </a:r>
           </a:p>
           <a:p>
@@ -4316,7 +4316,7 @@
               </a:defRPr>
             </a:pPr>
             <a:r>
-              <a:t>The LaundryCare Solution: 3 Unified Portals</a:t>
+              <a:t>The Solution: 3 Simple Portals for Everyone</a:t>
             </a:r>
           </a:p>
         </p:txBody>
@@ -4374,7 +4374,7 @@
               </a:defRPr>
             </a:pPr>
             <a:r>
-              <a:t>📱  Public Customer Portal</a:t>
+              <a:t>📱  1. For Customers</a:t>
             </a:r>
           </a:p>
           <a:p>
@@ -4393,7 +4393,7 @@
               </a:defRPr>
             </a:pPr>
             <a:r>
-              <a:t>•  Zero Login Required: Frictionless access for dormitory students and residents.</a:t>
+              <a:t>•  No Account Needed: Anyone can book without complicated registration.</a:t>
             </a:r>
           </a:p>
           <a:p>
@@ -4412,7 +4412,7 @@
               </a:defRPr>
             </a:pPr>
             <a:r>
-              <a:t>•  60-Second Online Booking (/book-pickup): Sector-based pickup scheduling.</a:t>
+              <a:t>•  Book in 1 Minute: Choose your neighborhood zone, date, and preferred time.</a:t>
             </a:r>
           </a:p>
           <a:p>
@@ -4431,7 +4431,7 @@
               </a:defRPr>
             </a:pPr>
             <a:r>
-              <a:t>•  Live Real-Time Tracker (/track): 5-step progress bar from intake to doorstep drop-off.</a:t>
+              <a:t>•  Live Laundry Tracker: Enter your tracking code to see 5 real-time stages from intake to doorstep delivery.</a:t>
             </a:r>
           </a:p>
           <a:p>
@@ -4450,7 +4450,7 @@
               </a:defRPr>
             </a:pPr>
             <a:r>
-              <a:t>•  Transparent Payments: Electronic GCash/Maya reference modal.</a:t>
+              <a:t>•  Easy Payment Info: Clear rates (₱50/kilo) with Cash on Delivery or GCash options.</a:t>
             </a:r>
           </a:p>
         </p:txBody>
@@ -4508,7 +4508,7 @@
               </a:defRPr>
             </a:pPr>
             <a:r>
-              <a:t>🧺  Cashier &amp; Wash Operations</a:t>
+              <a:t>🧺  2. For Shop Staff</a:t>
             </a:r>
           </a:p>
           <a:p>
@@ -4527,7 +4527,7 @@
               </a:defRPr>
             </a:pPr>
             <a:r>
-              <a:t>•  Customer CRM Directory (/customers-page): Lifetime spend &amp; loyalty tier tracking.</a:t>
+              <a:t>•  Customer Records: Easily search customer phone numbers and past orders.</a:t>
             </a:r>
           </a:p>
           <a:p>
@@ -4546,7 +4546,7 @@
               </a:defRPr>
             </a:pPr>
             <a:r>
-              <a:t>•  Digital Scale Intake (/laundry-orders-page): Auto-pricing calculation (Weight x Rate).</a:t>
+              <a:t>•  Order Encoding: Staff enters the weight in kg, and the system auto-computes the total bill.</a:t>
             </a:r>
           </a:p>
           <a:p>
@@ -4565,7 +4565,7 @@
               </a:defRPr>
             </a:pPr>
             <a:r>
-              <a:t>•  Wash Hub Monitor (/pickup-schedules-page): Live capacity telemetry for 6 washers &amp; 4 dryers.</a:t>
+              <a:t>•  Machine Telemetry: Shows how many washing machines and dryers are currently busy or free.</a:t>
             </a:r>
           </a:p>
           <a:p>
@@ -4584,7 +4584,7 @@
               </a:defRPr>
             </a:pPr>
             <a:r>
-              <a:t>•  Payments &amp; Settlement (/payments-page): Walk-in settlement &amp; POS payment recording.</a:t>
+              <a:t>•  Cashier Payments: Record customer payments (Cash/GCash) and print paper receipts.</a:t>
             </a:r>
           </a:p>
         </p:txBody>
@@ -4642,7 +4642,7 @@
               </a:defRPr>
             </a:pPr>
             <a:r>
-              <a:t>🛵  Rider Mobile Web App</a:t>
+              <a:t>🛵  3. For Delivery Riders</a:t>
             </a:r>
           </a:p>
           <a:p>
@@ -4661,7 +4661,7 @@
               </a:defRPr>
             </a:pPr>
             <a:r>
-              <a:t>•  Field Courier Interface (/rider-app): Optimized for motorcycle smartphone mounts.</a:t>
+              <a:t>•  Mobile-Friendly Screen: Designed to be easily used while mounted on a motorcycle.</a:t>
             </a:r>
           </a:p>
           <a:p>
@@ -4680,7 +4680,7 @@
               </a:defRPr>
             </a:pPr>
             <a:r>
-              <a:t>•  1-Tap GPS Navigation: Direct shortcuts into Google Maps &amp; Waze.</a:t>
+              <a:t>•  1-Tap GPS Button: Opens the customer's location directly in Google Maps or Waze.</a:t>
             </a:r>
           </a:p>
           <a:p>
@@ -4699,7 +4699,7 @@
               </a:defRPr>
             </a:pPr>
             <a:r>
-              <a:t>•  Quick Client Calling: 1-tap phone dialer for arrival coordination.</a:t>
+              <a:t>•  Call Customer: One tap to call the customer's phone when arriving.</a:t>
             </a:r>
           </a:p>
           <a:p>
@@ -4718,7 +4718,7 @@
               </a:defRPr>
             </a:pPr>
             <a:r>
-              <a:t>•  HTML5 Signature Canvas: Paperless touch signature handover.</a:t>
+              <a:t>•  Screen Signature: Customer signs with their finger on the screen as proof of delivery.</a:t>
             </a:r>
           </a:p>
         </p:txBody>
@@ -4822,7 +4822,7 @@
           </a:fontRef>
         </p:style>
         <p:txBody>
-          <a:bodyPr rtlCol="0" anchor="ctr" wrap="square" lIns="228600" tIns="109728" rIns="228600" bIns="91440"/>
+          <a:bodyPr rtlCol="0" anchor="ctr" wrap="square" lIns="274320" tIns="109728" rIns="228600" bIns="91440"/>
           <a:lstStyle/>
           <a:p>
             <a:pPr algn="ctr">
@@ -4834,7 +4834,7 @@
               </a:defRPr>
             </a:pPr>
             <a:r>
-              <a:t>PHASE 3: SOFTWARE ENGINEERING &amp; QA   •   PRESENTER: TRISTAN DAVE M. PLAZA (MOBILE UX LEAD &amp; COURIER 1)</a:t>
+              <a:t>ENGINEERING &amp; TESTING   •   PRESENTER: TRISTAN DAVE M. PLAZA (MOBILE APP &amp; RIDER 1)</a:t>
             </a:r>
           </a:p>
           <a:p>
@@ -4850,7 +4850,7 @@
               </a:defRPr>
             </a:pPr>
             <a:r>
-              <a:t>Engineering Integrity: Architecture, RBAC &amp; Test Evidence</a:t>
+              <a:t>How We Built &amp; Tested the System</a:t>
             </a:r>
           </a:p>
         </p:txBody>
@@ -4908,7 +4908,7 @@
               </a:defRPr>
             </a:pPr>
             <a:r>
-              <a:t>🏗️  Modular System Architecture</a:t>
+              <a:t>💻  How the System Works Behind the Scenes</a:t>
             </a:r>
           </a:p>
           <a:p>
@@ -4927,7 +4927,7 @@
               </a:defRPr>
             </a:pPr>
             <a:r>
-              <a:t>•  Backend Framework: Python 3 + Flask using 6 decoupled domain Blueprints (Customer, Order, Pickup, Delivery, Payment, Portal).</a:t>
+              <a:t>•  Built with Python &amp; Flask: A fast and lightweight web framework that runs smoothly on laptops and phones.</a:t>
             </a:r>
           </a:p>
           <a:p>
@@ -4946,7 +4946,7 @@
               </a:defRPr>
             </a:pPr>
             <a:r>
-              <a:t>•  Merge Conflict Prevention: Team members worked on separate controllers concurrently without Git collisions.</a:t>
+              <a:t>•  Organized Code: The project is divided into clean modules (Customers, Orders, Pickups, Deliveries, Payments) so team members can work together easily.</a:t>
             </a:r>
           </a:p>
           <a:p>
@@ -4965,7 +4965,7 @@
               </a:defRPr>
             </a:pPr>
             <a:r>
-              <a:t>•  Database Architecture: SQLite 3 with enforced foreign keys (PRAGMA foreign_keys = ON) and automatic cold-start migrations.</a:t>
+              <a:t>•  Secure Role Logins: Admin, Staff, and Riders each have their own login so staff only see what they need.</a:t>
             </a:r>
           </a:p>
           <a:p>
@@ -4984,26 +4984,7 @@
               </a:defRPr>
             </a:pPr>
             <a:r>
-              <a:t>•  Dual-Mode Error Handler: Returns JSON for AJAX fetch calls and branded HTML for browser navigation (zero stack trace leakage).</a:t>
-            </a:r>
-          </a:p>
-          <a:p>
-            <a:pPr>
-              <a:spcBef>
-                <a:spcPts val="400"/>
-              </a:spcBef>
-              <a:spcAft>
-                <a:spcPts val="400"/>
-              </a:spcAft>
-              <a:defRPr sz="1200">
-                <a:solidFill>
-                  <a:srgbClr val="475569"/>
-                </a:solidFill>
-                <a:latin typeface="Calibri"/>
-              </a:defRPr>
-            </a:pPr>
-            <a:r>
-              <a:t>•  Role-Based Access Control: Decorator checks session roles (Admin, Staff, Rider) preventing privilege escalation.</a:t>
+              <a:t>•  Reliable Database: Uses SQLite to store all orders, payments, and customer records safely.</a:t>
             </a:r>
           </a:p>
         </p:txBody>
@@ -5061,7 +5042,7 @@
               </a:defRPr>
             </a:pPr>
             <a:r>
-              <a:t>🛡️  Adversarial Security &amp; Test Evidence</a:t>
+              <a:t>🛡️  System Safety &amp; Automated Testing</a:t>
             </a:r>
           </a:p>
           <a:p>
@@ -5080,7 +5061,7 @@
               </a:defRPr>
             </a:pPr>
             <a:r>
-              <a:t>•  Stored XSS Sanitization (BUG-001): Regex-based tag stripper (strip_html_tags()) purges &lt;script&gt; and &lt;style&gt; tags before database storage.</a:t>
+              <a:t>•  No Invalid Inputs: System blocks accidental mistakes like negative weights, past dates, or empty names.</a:t>
             </a:r>
           </a:p>
           <a:p>
@@ -5099,7 +5080,7 @@
               </a:defRPr>
             </a:pPr>
             <a:r>
-              <a:t>•  Physical Capacity Ceiling (BUG-002): Caps single order weight at 150.0 kg. Oversized loads return HTTP 422 commercial warning.</a:t>
+              <a:t>•  79 / 79 Automated Tests Passed: We created 79 test programs to test every button, route, and calculation with zero errors.</a:t>
             </a:r>
           </a:p>
           <a:p>
@@ -5118,7 +5099,7 @@
               </a:defRPr>
             </a:pPr>
             <a:r>
-              <a:t>•  Historical Date Prevention (BUG-003): Dynamic min date attribute and server-side checks block bookings in the past.</a:t>
+              <a:t>•  Safe and Private: Protects against web attacks and prevents sensitive business reports from leaking.</a:t>
             </a:r>
           </a:p>
           <a:p>
@@ -5137,26 +5118,7 @@
               </a:defRPr>
             </a:pPr>
             <a:r>
-              <a:t>•  Modal Freezing Resolution (BUG-004): Universal Escape key event handler cleanly dismisses dialogs across all browsers.</a:t>
-            </a:r>
-          </a:p>
-          <a:p>
-            <a:pPr>
-              <a:spcBef>
-                <a:spcPts val="400"/>
-              </a:spcBef>
-              <a:spcAft>
-                <a:spcPts val="400"/>
-              </a:spcAft>
-              <a:defRPr sz="1200">
-                <a:solidFill>
-                  <a:srgbClr val="475569"/>
-                </a:solidFill>
-                <a:latin typeface="Calibri"/>
-              </a:defRPr>
-            </a:pPr>
-            <a:r>
-              <a:t>•  79 / 79 Passing Pytest Tests: 100% green suite validating RBAC, arithmetic precision, and adversarial boundary limits.</a:t>
+              <a:t>•  Always Online: Deployed live on the cloud (Render), ready to use anytime from anywhere in Base Camp.</a:t>
             </a:r>
           </a:p>
         </p:txBody>
@@ -5260,7 +5222,7 @@
           </a:fontRef>
         </p:style>
         <p:txBody>
-          <a:bodyPr rtlCol="0" anchor="ctr" wrap="square" lIns="228600" tIns="109728" rIns="228600" bIns="91440"/>
+          <a:bodyPr rtlCol="0" anchor="ctr" wrap="square" lIns="274320" tIns="109728" rIns="228600" bIns="91440"/>
           <a:lstStyle/>
           <a:p>
             <a:pPr algn="ctr">
@@ -5272,7 +5234,7 @@
               </a:defRPr>
             </a:pPr>
             <a:r>
-              <a:t>PHASE 4: OPERATIONS &amp; LIVE DEMONSTRATION   •   PRESENTER: MARVIN OCLARINO (FINANCIAL SETTLEMENT LEAD &amp; COURIER 2)</a:t>
+              <a:t>OPERATIONS &amp; DEMO   •   PRESENTER: MARVIN OCLARINO (PAYMENTS &amp; RIDER 2)</a:t>
             </a:r>
           </a:p>
           <a:p>
@@ -5288,7 +5250,7 @@
               </a:defRPr>
             </a:pPr>
             <a:r>
-              <a:t>Motorcycle Logistics, POS Settlement &amp; Live System Demo</a:t>
+              <a:t>Motorcycle Logistics &amp; Live System Demonstration</a:t>
             </a:r>
           </a:p>
         </p:txBody>
@@ -5346,7 +5308,7 @@
               </a:defRPr>
             </a:pPr>
             <a:r>
-              <a:t>🗺️  Base Camp Bajaj Motorcycle Logistics</a:t>
+              <a:t>🛵  Motorcycle Delivery in Base Camp</a:t>
             </a:r>
           </a:p>
           <a:p>
@@ -5365,7 +5327,7 @@
               </a:defRPr>
             </a:pPr>
             <a:r>
-              <a:t>•  Exclusive Barangay Coverage: Central washing hub located at Base Camp Proper.</a:t>
+              <a:t>•  Central Hub: Main laundry facility located at Base Camp Proper.</a:t>
             </a:r>
           </a:p>
           <a:p>
@@ -5384,7 +5346,7 @@
               </a:defRPr>
             </a:pPr>
             <a:r>
-              <a:t>•  Zone 1 (Proper &amp; Commercial Junction): Dispatched to Tristan Dave Plaza (Bajaj Moto 1).</a:t>
+              <a:t>•  Zone 1 (Base Camp Proper &amp; Junction): Handled by Tristan Dave Plaza (Bajaj Moto 1).</a:t>
             </a:r>
           </a:p>
           <a:p>
@@ -5403,7 +5365,7 @@
               </a:defRPr>
             </a:pPr>
             <a:r>
-              <a:t>•  Zone 2 (Sayre Highway Corridor &amp; Strip): Dispatched to Marvin Oclarino (Bajaj Moto 2).</a:t>
+              <a:t>•  Zone 2 (Sayre Highway Corridor): Handled by Marvin Oclarino (Bajaj Moto 2).</a:t>
             </a:r>
           </a:p>
           <a:p>
@@ -5422,7 +5384,7 @@
               </a:defRPr>
             </a:pPr>
             <a:r>
-              <a:t>•  Zone 3 (Puroks 1 to 5 Residential): Dispatched to Mark Ephraim Nicor (Bajaj Moto 3).</a:t>
+              <a:t>•  Zone 3 (Puroks 1 to 5 Residential): Handled by Mark Ephraim Nicor (Bajaj Moto 3).</a:t>
             </a:r>
           </a:p>
           <a:p>
@@ -5441,7 +5403,7 @@
               </a:defRPr>
             </a:pPr>
             <a:r>
-              <a:t>•  Smart Sector Dispatch: Booking engine automatically resolves addresses into courier assignments.</a:t>
+              <a:t>•  Automatic Assignment: The system reads the customer's barangay zone and assigns the right rider.</a:t>
             </a:r>
           </a:p>
         </p:txBody>
@@ -5499,7 +5461,7 @@
               </a:defRPr>
             </a:pPr>
             <a:r>
-              <a:t>💳  Doorstep Financial POS &amp; Contact Hub</a:t>
+              <a:t>💳  Payments, Receipts &amp; Support</a:t>
             </a:r>
           </a:p>
           <a:p>
@@ -5518,7 +5480,7 @@
               </a:defRPr>
             </a:pPr>
             <a:r>
-              <a:t>•  Courier Cash Change Helper: Real-time calculation displays exact change in green or a bold red alert (Short: ₱XX.XX).</a:t>
+              <a:t>•  Change Calculator: Shows rider the exact change to give the customer to avoid mistakes.</a:t>
             </a:r>
           </a:p>
           <a:p>
@@ -5537,7 +5499,7 @@
               </a:defRPr>
             </a:pPr>
             <a:r>
-              <a:t>•  80mm Thermal Bluetooth Print: POS receipt modal formatted for thermal paper with zero-dependency inline SVG Code128 barcode.</a:t>
+              <a:t>•  Thermal Receipts: Prints clean 80mm laundry receipts with barcodes for easy pickup.</a:t>
             </a:r>
           </a:p>
           <a:p>
@@ -5556,7 +5518,7 @@
               </a:defRPr>
             </a:pPr>
             <a:r>
-              <a:t>•  Customer Hotline &amp; Socials: Official Hotline 0906-188-8611 • Store Hours: 8:00 AM - 4:30 PM (Mon-Sat).</a:t>
+              <a:t>•  Official Hotline: 0906-188-8611 (Calls &amp; SMS).</a:t>
             </a:r>
           </a:p>
           <a:p>
@@ -5575,7 +5537,26 @@
               </a:defRPr>
             </a:pPr>
             <a:r>
-              <a:t>•  Official Facebook Page: Direct integration to https://www.facebook.com/LaundryCare.</a:t>
+              <a:t>•  Store Hours: 8:00 AM to 4:30 PM, Monday to Saturday (Closed Sundays).</a:t>
+            </a:r>
+          </a:p>
+          <a:p>
+            <a:pPr>
+              <a:spcBef>
+                <a:spcPts val="400"/>
+              </a:spcBef>
+              <a:spcAft>
+                <a:spcPts val="400"/>
+              </a:spcAft>
+              <a:defRPr sz="1200">
+                <a:solidFill>
+                  <a:srgbClr val="475569"/>
+                </a:solidFill>
+                <a:latin typeface="Calibri"/>
+              </a:defRPr>
+            </a:pPr>
+            <a:r>
+              <a:t>•  Official Facebook Page: facebook.com/LaundryCare.</a:t>
             </a:r>
           </a:p>
         </p:txBody>
@@ -5630,7 +5611,7 @@
               </a:defRPr>
             </a:pPr>
             <a:r>
-              <a:t>LIVE SYSTEM DEMONSTRATION WORKFLOW  •  TRANSITIONING TO APPLICATION</a:t>
+              <a:t>NOW STARTING THE LIVE SYSTEM DEMONSTRATION</a:t>
             </a:r>
           </a:p>
           <a:p>
@@ -5646,7 +5627,7 @@
               </a:defRPr>
             </a:pPr>
             <a:r>
-              <a:t>Demo Steps: 1. Public 60s Booking (/book-pickup)  ➔  2. Scale Weighing &amp; Pricing (/laundry-orders-page)  ➔  3. Wash Hub Telemetry (/pickup-schedules-page)  ➔  4. Customer Tracker (/track)  ➔  5. Mobile Courier Touch Signature (/rider-app)  ➔  6. Thermal POS Receipt &amp; Payment Settlement (/payments-page).</a:t>
+              <a:t>Demo Flow: 1. Customer Books Online  ➔  2. Staff Encodes Weight &amp; Computes Bill  ➔  3. Machine Telemetry Status  ➔  4. Customer Checks Live Tracker  ➔  5. Rider Delivers &amp; Gets Finger Signature  ➔  6. Cashier Records Payment &amp; Prints Receipt.</a:t>
             </a:r>
           </a:p>
         </p:txBody>

</xml_diff>

<commit_message>
Relocate LaundryCare hub to P2B Sayre Highway, Panadtalan (Near Torres Capitol College Inc.), update 5-slide PPTX, and generate new TCCI Facebook cover photo
</commit_message>
<xml_diff>
--- a/LaundryCare_Presentation.pptx
+++ b/LaundryCare_Presentation.pptx
@@ -3215,7 +3215,7 @@
               </a:defRPr>
             </a:pPr>
             <a:r>
-              <a:t>Doorstep Laundry Pickup and Delivery System for Base Camp, Maramag, Bukidnon</a:t>
+              <a:t>Doorstep Laundry Pickup &amp; Delivery System | P2B Sayre Highway, Panadtalan, Maramag (Near Torres Capitol College Inc.)</a:t>
             </a:r>
           </a:p>
         </p:txBody>
@@ -3360,7 +3360,7 @@
               </a:defRPr>
             </a:pPr>
             <a:r>
-              <a:t>    Role: Washing and drying schedule, deliveries for Puroks 1-5</a:t>
+              <a:t>    Role: Washing and drying schedule, deliveries across Panadtalan Puroks 1-5</a:t>
             </a:r>
           </a:p>
           <a:p>
@@ -3389,7 +3389,7 @@
               </a:defRPr>
             </a:pPr>
             <a:r>
-              <a:t>    Role: Rider mobile view, digital signature, deliveries for Base Camp Proper</a:t>
+              <a:t>    Role: Rider mobile view, digital signature, deliveries for Torres Capitol College Inc. &amp; Dorms</a:t>
             </a:r>
           </a:p>
           <a:p>
@@ -3418,7 +3418,7 @@
               </a:defRPr>
             </a:pPr>
             <a:r>
-              <a:t>    Role: Payment recording, change calculator, deliveries along Highway</a:t>
+              <a:t>    Role: Payment recording, change calculator, deliveries along Sayre Highway</a:t>
             </a:r>
           </a:p>
         </p:txBody>
@@ -3505,7 +3505,7 @@
               </a:defRPr>
             </a:pPr>
             <a:r>
-              <a:t>Exclusively serves Barangay Base Camp, Maramag, Bukidnon.</a:t>
+              <a:t>Near Torres Capitol College Inc., P2B Sayre Highway, Panadtalan, Maramag.</a:t>
             </a:r>
           </a:p>
           <a:p>
@@ -5118,7 +5118,7 @@
               </a:defRPr>
             </a:pPr>
             <a:r>
-              <a:t>•  Always Online: Deployed live on the cloud (Render), ready to use anytime from anywhere in Base Camp.</a:t>
+              <a:t>•  Always Online: Deployed live on the cloud (Render), ready to use anytime from anywhere across Panadtalan and school campus.</a:t>
             </a:r>
           </a:p>
         </p:txBody>
@@ -5308,7 +5308,7 @@
               </a:defRPr>
             </a:pPr>
             <a:r>
-              <a:t>🛵  Motorcycle Delivery in Base Camp</a:t>
+              <a:t>🛵  Bajaj Motorcycle Delivery in Panadtalan</a:t>
             </a:r>
           </a:p>
           <a:p>
@@ -5327,7 +5327,7 @@
               </a:defRPr>
             </a:pPr>
             <a:r>
-              <a:t>•  Central Hub: Main laundry facility located at Base Camp Proper.</a:t>
+              <a:t>•  Central Hub: Main laundry hub located at P2B Sayre Highway, Panadtalan (Near Torres Capitol College Inc.).</a:t>
             </a:r>
           </a:p>
           <a:p>
@@ -5346,7 +5346,7 @@
               </a:defRPr>
             </a:pPr>
             <a:r>
-              <a:t>•  Zone 1 (Base Camp Proper &amp; Junction): Handled by Tristan Dave Plaza (Bajaj Moto 1).</a:t>
+              <a:t>•  Zone 1 (Torres Capitol College Inc. &amp; Dorms): Handled by Tristan Dave Plaza (Bajaj Moto 1).</a:t>
             </a:r>
           </a:p>
           <a:p>
@@ -5365,7 +5365,7 @@
               </a:defRPr>
             </a:pPr>
             <a:r>
-              <a:t>•  Zone 2 (Sayre Highway Corridor): Handled by Marvin Oclarino (Bajaj Moto 2).</a:t>
+              <a:t>•  Zone 2 (Sayre Highway Commercial Corridor): Handled by Marvin Oclarino (Bajaj Moto 2).</a:t>
             </a:r>
           </a:p>
           <a:p>
@@ -5384,7 +5384,7 @@
               </a:defRPr>
             </a:pPr>
             <a:r>
-              <a:t>•  Zone 3 (Puroks 1 to 5 Residential): Handled by Mark Ephraim Nicor (Bajaj Moto 3).</a:t>
+              <a:t>•  Zone 3 (Panadtalan Puroks 1 to 5 Residential): Handled by Mark Ephraim Nicor (Bajaj Moto 3).</a:t>
             </a:r>
           </a:p>
           <a:p>
@@ -5403,7 +5403,7 @@
               </a:defRPr>
             </a:pPr>
             <a:r>
-              <a:t>•  Automatic Assignment: The system reads the customer's barangay zone and assigns the right rider.</a:t>
+              <a:t>•  Automatic Assignment: The system matches student dorms, campus gates, or puroks to the assigned courier.</a:t>
             </a:r>
           </a:p>
         </p:txBody>

</xml_diff>

<commit_message>
Integrate official LaundryCare logo, circular emblem, and favicons across all 24 templates, static assets, and 5-slide presentation
</commit_message>
<xml_diff>
--- a/LaundryCare_Presentation.pptx
+++ b/LaundryCare_Presentation.pptx
@@ -3228,6 +3228,73 @@
         </p:nvSpPr>
         <p:spPr>
           <a:xfrm>
+            <a:off x="9692640" y="594360"/>
+            <a:ext cx="1600200" cy="1600200"/>
+          </a:xfrm>
+          <a:prstGeom prst="roundRect">
+            <a:avLst/>
+          </a:prstGeom>
+          <a:solidFill>
+            <a:srgbClr val="FFFFFF"/>
+          </a:solidFill>
+          <a:ln>
+            <a:noFill/>
+          </a:ln>
+        </p:spPr>
+        <p:style>
+          <a:lnRef idx="1">
+            <a:schemeClr val="accent1"/>
+          </a:lnRef>
+          <a:fillRef idx="3">
+            <a:schemeClr val="accent1"/>
+          </a:fillRef>
+          <a:effectRef idx="2">
+            <a:schemeClr val="accent1"/>
+          </a:effectRef>
+          <a:fontRef idx="minor">
+            <a:schemeClr val="lt1"/>
+          </a:fontRef>
+        </p:style>
+        <p:txBody>
+          <a:bodyPr rtlCol="0" anchor="ctr"/>
+          <a:lstStyle/>
+          <a:p>
+            <a:pPr algn="ctr"/>
+          </a:p>
+        </p:txBody>
+      </p:sp>
+      <p:pic>
+        <p:nvPicPr>
+          <p:cNvPr id="5" name="Picture 4" descr="logo_icon.png"/>
+          <p:cNvPicPr>
+            <a:picLocks noChangeAspect="1"/>
+          </p:cNvPicPr>
+          <p:nvPr/>
+        </p:nvPicPr>
+        <p:blipFill>
+          <a:blip r:embed="rId2"/>
+          <a:stretch>
+            <a:fillRect/>
+          </a:stretch>
+        </p:blipFill>
+        <p:spPr>
+          <a:xfrm>
+            <a:off x="9784080" y="685800"/>
+            <a:ext cx="1417320" cy="1417320"/>
+          </a:xfrm>
+          <a:prstGeom prst="rect">
+            <a:avLst/>
+          </a:prstGeom>
+        </p:spPr>
+      </p:pic>
+      <p:sp>
+        <p:nvSpPr>
+          <p:cNvPr id="6" name="Rounded Rectangle 5"/>
+          <p:cNvSpPr/>
+          <p:nvPr/>
+        </p:nvSpPr>
+        <p:spPr>
+          <a:xfrm>
             <a:off x="731520" y="2697480"/>
             <a:ext cx="6858000" cy="3657600"/>
           </a:xfrm>
@@ -3425,7 +3492,7 @@
       </p:sp>
       <p:sp>
         <p:nvSpPr>
-          <p:cNvPr id="5" name="Rounded Rectangle 4"/>
+          <p:cNvPr id="7" name="Rounded Rectangle 6"/>
           <p:cNvSpPr/>
           <p:nvPr/>
         </p:nvSpPr>

</xml_diff>

<commit_message>
Fix sidebar logo size overflow across all pages and update Panadtalan TCCI sector filter
</commit_message>
<xml_diff>
--- a/LaundryCare_Presentation.pptx
+++ b/LaundryCare_Presentation.pptx
@@ -3849,7 +3849,7 @@
               </a:defRPr>
             </a:pPr>
             <a:r>
-              <a:t>🏷️  Lost Paper Slips</a:t>
+              <a:t>🎓  College Students &amp; Dormers Struggle with Laundry</a:t>
             </a:r>
           </a:p>
           <a:p>
@@ -3868,7 +3868,7 @@
               </a:defRPr>
             </a:pPr>
             <a:r>
-              <a:t>•  Paper receipts get wet, torn, or misplaced on the counter.</a:t>
+              <a:t>•  Students have heavy class loads and limited time to wash clothes.</a:t>
             </a:r>
           </a:p>
           <a:p>
@@ -3887,7 +3887,7 @@
               </a:defRPr>
             </a:pPr>
             <a:r>
-              <a:t>•  Handwritten tags fall off bags, causing mixed-up clothes.</a:t>
+              <a:t>•  Dorms and boarding houses lack water and drying space, especially when it rains.</a:t>
             </a:r>
           </a:p>
           <a:p>
@@ -3906,7 +3906,7 @@
               </a:defRPr>
             </a:pPr>
             <a:r>
-              <a:t>•  Hard to look up past customer records when using paper notebooks.</a:t>
+              <a:t>•  Carrying heavy laundry bags down Sayre Highway is exhausting.</a:t>
             </a:r>
           </a:p>
         </p:txBody>
@@ -3964,7 +3964,7 @@
               </a:defRPr>
             </a:pPr>
             <a:r>
-              <a:t>👀  No Status Tracking</a:t>
+              <a:t>📝  Inefficient and Fragile Manual Record-Keeping</a:t>
             </a:r>
           </a:p>
           <a:p>
@@ -3983,7 +3983,7 @@
               </a:defRPr>
             </a:pPr>
             <a:r>
-              <a:t>•  Customers don't know if their clothes are currently being washed or dried.</a:t>
+              <a:t>•  Paper receipts and tags tear, get wet, or get misplaced on the counter.</a:t>
             </a:r>
           </a:p>
           <a:p>
@@ -4002,7 +4002,7 @@
               </a:defRPr>
             </a:pPr>
             <a:r>
-              <a:t>•  Students and busy families keep calling to ask if their laundry is ready.</a:t>
+              <a:t>•  Detached tags cause clothes to be mixed up between different customers.</a:t>
             </a:r>
           </a:p>
           <a:p>
@@ -4021,7 +4021,7 @@
               </a:defRPr>
             </a:pPr>
             <a:r>
-              <a:t>•  No notifications sent when riders are already on the way.</a:t>
+              <a:t>•  Staff must flip through paper notebooks to search past records.</a:t>
             </a:r>
           </a:p>
         </p:txBody>
@@ -4079,7 +4079,7 @@
               </a:defRPr>
             </a:pPr>
             <a:r>
-              <a:t>🛵  Messy Delivery Dispatch</a:t>
+              <a:t>🔍  Total Lack of Order Visibility for Customers</a:t>
             </a:r>
           </a:p>
           <a:p>
@@ -4098,7 +4098,7 @@
               </a:defRPr>
             </a:pPr>
             <a:r>
-              <a:t>•  Riders only get text messages without clear addresses or landmarks.</a:t>
+              <a:t>•  Customers don't know if clothes are currently being washed, dried, or folded.</a:t>
             </a:r>
           </a:p>
           <a:p>
@@ -4117,7 +4117,7 @@
               </a:defRPr>
             </a:pPr>
             <a:r>
-              <a:t>•  Riders overlap in the same area, wasting time and motorcycle fuel.</a:t>
+              <a:t>•  Students panic about whether uniforms will be ready for class.</a:t>
             </a:r>
           </a:p>
           <a:p>
@@ -4136,7 +4136,7 @@
               </a:defRPr>
             </a:pPr>
             <a:r>
-              <a:t>•  Too many pickup requests during peak hours can overwhelm riders.</a:t>
+              <a:t>•  Customers repeatedly call and text the shop, interrupting staff work.</a:t>
             </a:r>
           </a:p>
         </p:txBody>
@@ -4194,7 +4194,7 @@
               </a:defRPr>
             </a:pPr>
             <a:r>
-              <a:t>🧮  Manual Math &amp; Change Errors</a:t>
+              <a:t>✍️  Absence of Verifiable Proof of Delivery</a:t>
             </a:r>
           </a:p>
           <a:p>
@@ -4213,7 +4213,7 @@
               </a:defRPr>
             </a:pPr>
             <a:r>
-              <a:t>•  Riders calculate rates and change in their head at the doorstep.</a:t>
+              <a:t>•  No signed proof or timestamp when clothes are delivered to gates or dorms.</a:t>
             </a:r>
           </a:p>
           <a:p>
@@ -4232,7 +4232,7 @@
               </a:defRPr>
             </a:pPr>
             <a:r>
-              <a:t>•  Mental math mistakes cause short cash at the end of the day.</a:t>
+              <a:t>•  Packages left with roommates or caretakers risk being lost or misplaced.</a:t>
             </a:r>
           </a:p>
           <a:p>
@@ -4251,7 +4251,7 @@
               </a:defRPr>
             </a:pPr>
             <a:r>
-              <a:t>•  No digital signature or proof that the laundry was actually received.</a:t>
+              <a:t>•  Unresolvable disputes between customers and riders with no audit trail.</a:t>
             </a:r>
           </a:p>
         </p:txBody>

</xml_diff>